<commit_message>
Added material for BDA tutorial
</commit_message>
<xml_diff>
--- a/slides/presentations/2024-10-18-seminar-upc.pptx
+++ b/slides/presentations/2024-10-18-seminar-upc.pptx
@@ -5,7 +5,7 @@
     <p:sldMasterId id="2147483648" r:id="rId1"/>
   </p:sldMasterIdLst>
   <p:notesMasterIdLst>
-    <p:notesMasterId r:id="rId60"/>
+    <p:notesMasterId r:id="rId62"/>
   </p:notesMasterIdLst>
   <p:sldIdLst>
     <p:sldId id="256" r:id="rId2"/>
@@ -56,16 +56,18 @@
     <p:sldId id="281" r:id="rId47"/>
     <p:sldId id="283" r:id="rId48"/>
     <p:sldId id="284" r:id="rId49"/>
-    <p:sldId id="316" r:id="rId50"/>
-    <p:sldId id="318" r:id="rId51"/>
-    <p:sldId id="322" r:id="rId52"/>
-    <p:sldId id="319" r:id="rId53"/>
-    <p:sldId id="320" r:id="rId54"/>
-    <p:sldId id="321" r:id="rId55"/>
-    <p:sldId id="323" r:id="rId56"/>
-    <p:sldId id="287" r:id="rId57"/>
-    <p:sldId id="286" r:id="rId58"/>
-    <p:sldId id="289" r:id="rId59"/>
+    <p:sldId id="324" r:id="rId50"/>
+    <p:sldId id="325" r:id="rId51"/>
+    <p:sldId id="316" r:id="rId52"/>
+    <p:sldId id="318" r:id="rId53"/>
+    <p:sldId id="322" r:id="rId54"/>
+    <p:sldId id="319" r:id="rId55"/>
+    <p:sldId id="320" r:id="rId56"/>
+    <p:sldId id="321" r:id="rId57"/>
+    <p:sldId id="323" r:id="rId58"/>
+    <p:sldId id="287" r:id="rId59"/>
+    <p:sldId id="286" r:id="rId60"/>
+    <p:sldId id="289" r:id="rId61"/>
   </p:sldIdLst>
   <p:sldSz cx="12192000" cy="6858000"/>
   <p:notesSz cx="6858000" cy="9144000"/>
@@ -254,7 +256,7 @@
           <a:p>
             <a:fld id="{932107E3-02B0-4F32-9595-48F976375028}" type="datetimeFigureOut">
               <a:rPr lang="en-US" smtClean="0"/>
-              <a:t>4/3/2025</a:t>
+              <a:t>4/13/2026</a:t>
             </a:fld>
             <a:endParaRPr lang="en-US"/>
           </a:p>
@@ -2444,7 +2446,7 @@
           <a:p>
             <a:fld id="{E7726789-9A4A-4BF5-9E9B-3B6C777735E6}" type="slidenum">
               <a:rPr lang="en-US" smtClean="0"/>
-              <a:t>57</a:t>
+              <a:t>59</a:t>
             </a:fld>
             <a:endParaRPr lang="en-US"/>
           </a:p>
@@ -2551,7 +2553,7 @@
           <a:p>
             <a:fld id="{E7726789-9A4A-4BF5-9E9B-3B6C777735E6}" type="slidenum">
               <a:rPr lang="en-US" smtClean="0"/>
-              <a:t>58</a:t>
+              <a:t>60</a:t>
             </a:fld>
             <a:endParaRPr lang="en-US"/>
           </a:p>
@@ -28872,7 +28874,7 @@
           <p:cNvPr id="2" name="Title 1">
             <a:extLst>
               <a:ext uri="{FF2B5EF4-FFF2-40B4-BE49-F238E27FC236}">
-                <a16:creationId xmlns:a16="http://schemas.microsoft.com/office/drawing/2014/main" id="{3CC60B4B-88BC-CFD5-84E5-9BE4E0E29223}"/>
+                <a16:creationId xmlns:a16="http://schemas.microsoft.com/office/drawing/2014/main" id="{E566BBAE-F974-E10D-04D2-65A5C7C195FA}"/>
               </a:ext>
             </a:extLst>
           </p:cNvPr>
@@ -28889,75 +28891,9 @@
           <a:lstStyle/>
           <a:p>
             <a:r>
-              <a:rPr lang="en-US" dirty="0"/>
-              <a:t>Demonstration of the Bayesian Approach</a:t>
-            </a:r>
-          </a:p>
-        </p:txBody>
-      </p:sp>
-      <p:sp>
-        <p:nvSpPr>
-          <p:cNvPr id="3" name="Content Placeholder 2">
-            <a:extLst>
-              <a:ext uri="{FF2B5EF4-FFF2-40B4-BE49-F238E27FC236}">
-                <a16:creationId xmlns:a16="http://schemas.microsoft.com/office/drawing/2014/main" id="{AE6DDF7A-9D5F-F440-7B32-642DD080540C}"/>
-              </a:ext>
-            </a:extLst>
-          </p:cNvPr>
-          <p:cNvSpPr>
-            <a:spLocks noGrp="1"/>
-          </p:cNvSpPr>
-          <p:nvPr>
-            <p:ph idx="1"/>
-          </p:nvPr>
-        </p:nvSpPr>
-        <p:spPr>
-          <a:xfrm>
-            <a:off x="838200" y="1825625"/>
-            <a:ext cx="10515600" cy="1112647"/>
-          </a:xfrm>
-        </p:spPr>
-        <p:txBody>
-          <a:bodyPr/>
-          <a:lstStyle/>
-          <a:p>
-            <a:pPr marL="514350" indent="-514350">
-              <a:buFont typeface="+mj-lt"/>
-              <a:buAutoNum type="arabicPeriod" startAt="2"/>
-            </a:pPr>
-            <a:r>
-              <a:rPr lang="en-US" dirty="0"/>
-              <a:t>Determine </a:t>
-            </a:r>
-            <a:r>
-              <a:rPr lang="en-US" b="1" dirty="0"/>
-              <a:t>model distribution</a:t>
-            </a:r>
-          </a:p>
-          <a:p>
-            <a:pPr marL="514350" indent="-514350">
-              <a:buFont typeface="+mj-lt"/>
-              <a:buAutoNum type="arabicPeriod" startAt="2"/>
-            </a:pPr>
-            <a:r>
-              <a:rPr lang="en-US" dirty="0"/>
-              <a:t>Select </a:t>
-            </a:r>
-            <a:r>
-              <a:rPr lang="en-US" b="1" dirty="0"/>
-              <a:t>priors</a:t>
-            </a:r>
-            <a:r>
-              <a:rPr lang="en-US" dirty="0"/>
-              <a:t> for all included factors</a:t>
-            </a:r>
-            <a:endParaRPr lang="en-US" b="1" dirty="0"/>
-          </a:p>
-          <a:p>
-            <a:pPr marL="0" indent="0">
-              <a:buNone/>
-            </a:pPr>
-            <a:endParaRPr lang="en-US" b="1" dirty="0"/>
+              <a:rPr lang="en-SE" dirty="0"/>
+              <a:t>Determining the Model Distribution</a:t>
+            </a:r>
           </a:p>
         </p:txBody>
       </p:sp>
@@ -28966,7 +28902,7 @@
           <p:cNvPr id="4" name="Date Placeholder 3">
             <a:extLst>
               <a:ext uri="{FF2B5EF4-FFF2-40B4-BE49-F238E27FC236}">
-                <a16:creationId xmlns:a16="http://schemas.microsoft.com/office/drawing/2014/main" id="{79DFEEAF-0645-40DC-1613-53DC1272DA26}"/>
+                <a16:creationId xmlns:a16="http://schemas.microsoft.com/office/drawing/2014/main" id="{00113590-E718-61A6-64BC-407345762C1D}"/>
               </a:ext>
             </a:extLst>
           </p:cNvPr>
@@ -28994,7 +28930,7 @@
           <p:cNvPr id="5" name="Footer Placeholder 4">
             <a:extLst>
               <a:ext uri="{FF2B5EF4-FFF2-40B4-BE49-F238E27FC236}">
-                <a16:creationId xmlns:a16="http://schemas.microsoft.com/office/drawing/2014/main" id="{C98C849D-2278-2A3E-2143-3AE40709C946}"/>
+                <a16:creationId xmlns:a16="http://schemas.microsoft.com/office/drawing/2014/main" id="{DE839B28-7FB4-EFF0-388C-EDDE9CB05837}"/>
               </a:ext>
             </a:extLst>
           </p:cNvPr>
@@ -29022,7 +28958,7 @@
           <p:cNvPr id="6" name="Slide Number Placeholder 5">
             <a:extLst>
               <a:ext uri="{FF2B5EF4-FFF2-40B4-BE49-F238E27FC236}">
-                <a16:creationId xmlns:a16="http://schemas.microsoft.com/office/drawing/2014/main" id="{FE3FC949-DD4C-284A-2B86-13FADF39C339}"/>
+                <a16:creationId xmlns:a16="http://schemas.microsoft.com/office/drawing/2014/main" id="{C9F267CF-0059-82D2-4A66-E6A367C583A4}"/>
               </a:ext>
             </a:extLst>
           </p:cNvPr>
@@ -29048,10 +28984,10 @@
       </p:sp>
       <p:pic>
         <p:nvPicPr>
-          <p:cNvPr id="13" name="Picture 12">
-            <a:extLst>
-              <a:ext uri="{FF2B5EF4-FFF2-40B4-BE49-F238E27FC236}">
-                <a16:creationId xmlns:a16="http://schemas.microsoft.com/office/drawing/2014/main" id="{4DCD1F97-35CA-8612-A0BF-51F62C52C82E}"/>
+          <p:cNvPr id="8" name="Picture 7">
+            <a:extLst>
+              <a:ext uri="{FF2B5EF4-FFF2-40B4-BE49-F238E27FC236}">
+                <a16:creationId xmlns:a16="http://schemas.microsoft.com/office/drawing/2014/main" id="{5A3D7094-F78A-7DC6-6D92-3BFF59C34183}"/>
               </a:ext>
             </a:extLst>
           </p:cNvPr>
@@ -29061,15 +28997,21 @@
           <p:nvPr/>
         </p:nvPicPr>
         <p:blipFill>
-          <a:blip r:embed="rId2"/>
+          <a:blip r:embed="rId2">
+            <a:extLst>
+              <a:ext uri="{28A0092B-C50C-407E-A947-70E740481C1C}">
+                <a14:useLocalDpi xmlns:a14="http://schemas.microsoft.com/office/drawing/2010/main" val="0"/>
+              </a:ext>
+            </a:extLst>
+          </a:blip>
           <a:stretch>
             <a:fillRect/>
           </a:stretch>
         </p:blipFill>
         <p:spPr>
           <a:xfrm>
-            <a:off x="838200" y="3326511"/>
-            <a:ext cx="6743700" cy="2228850"/>
+            <a:off x="8153399" y="4195058"/>
+            <a:ext cx="3599695" cy="2157988"/>
           </a:xfrm>
           <a:prstGeom prst="rect">
             <a:avLst/>
@@ -29078,10 +29020,10 @@
       </p:pic>
       <p:pic>
         <p:nvPicPr>
-          <p:cNvPr id="15" name="Picture 14">
-            <a:extLst>
-              <a:ext uri="{FF2B5EF4-FFF2-40B4-BE49-F238E27FC236}">
-                <a16:creationId xmlns:a16="http://schemas.microsoft.com/office/drawing/2014/main" id="{0DD349AB-B2EE-FCE0-ACFC-38D85A46EEC2}"/>
+          <p:cNvPr id="10" name="Picture 9">
+            <a:extLst>
+              <a:ext uri="{FF2B5EF4-FFF2-40B4-BE49-F238E27FC236}">
+                <a16:creationId xmlns:a16="http://schemas.microsoft.com/office/drawing/2014/main" id="{B2165A17-51C2-0022-2606-7B2824546371}"/>
               </a:ext>
             </a:extLst>
           </p:cNvPr>
@@ -29091,210 +29033,1693 @@
           <p:nvPr/>
         </p:nvPicPr>
         <p:blipFill>
-          <a:blip r:embed="rId3"/>
+          <a:blip r:embed="rId3">
+            <a:extLst>
+              <a:ext uri="{28A0092B-C50C-407E-A947-70E740481C1C}">
+                <a14:useLocalDpi xmlns:a14="http://schemas.microsoft.com/office/drawing/2010/main" val="0"/>
+              </a:ext>
+            </a:extLst>
+          </a:blip>
           <a:stretch>
             <a:fillRect/>
           </a:stretch>
         </p:blipFill>
         <p:spPr>
           <a:xfrm>
-            <a:off x="7820977" y="3429000"/>
-            <a:ext cx="3743325" cy="914400"/>
+            <a:off x="4325114" y="2759443"/>
+            <a:ext cx="3599695" cy="2157988"/>
           </a:xfrm>
           <a:prstGeom prst="rect">
             <a:avLst/>
           </a:prstGeom>
         </p:spPr>
       </p:pic>
-      <p:sp>
-        <p:nvSpPr>
-          <p:cNvPr id="7" name="Rectangle 6">
-            <a:extLst>
-              <a:ext uri="{FF2B5EF4-FFF2-40B4-BE49-F238E27FC236}">
-                <a16:creationId xmlns:a16="http://schemas.microsoft.com/office/drawing/2014/main" id="{19EFAC25-EBDD-D08F-73C8-ECED879F2850}"/>
-              </a:ext>
-            </a:extLst>
-          </p:cNvPr>
-          <p:cNvSpPr/>
+      <p:pic>
+        <p:nvPicPr>
+          <p:cNvPr id="12" name="Picture 11">
+            <a:extLst>
+              <a:ext uri="{FF2B5EF4-FFF2-40B4-BE49-F238E27FC236}">
+                <a16:creationId xmlns:a16="http://schemas.microsoft.com/office/drawing/2014/main" id="{3F7565D2-F9A9-6223-A6E4-11D8F458D5D2}"/>
+              </a:ext>
+            </a:extLst>
+          </p:cNvPr>
+          <p:cNvPicPr>
+            <a:picLocks noChangeAspect="1"/>
+          </p:cNvPicPr>
           <p:nvPr/>
-        </p:nvSpPr>
+        </p:nvPicPr>
+        <p:blipFill>
+          <a:blip r:embed="rId4">
+            <a:extLst>
+              <a:ext uri="{28A0092B-C50C-407E-A947-70E740481C1C}">
+                <a14:useLocalDpi xmlns:a14="http://schemas.microsoft.com/office/drawing/2010/main" val="0"/>
+              </a:ext>
+            </a:extLst>
+          </a:blip>
+          <a:stretch>
+            <a:fillRect/>
+          </a:stretch>
+        </p:blipFill>
         <p:spPr>
           <a:xfrm>
-            <a:off x="1354824" y="3886200"/>
-            <a:ext cx="1374090" cy="200025"/>
+            <a:off x="8153400" y="1343770"/>
+            <a:ext cx="3599695" cy="2157988"/>
           </a:xfrm>
           <a:prstGeom prst="rect">
             <a:avLst/>
           </a:prstGeom>
-          <a:solidFill>
-            <a:schemeClr val="accent1">
-              <a:lumMod val="40000"/>
-              <a:lumOff val="60000"/>
-              <a:alpha val="40000"/>
-            </a:schemeClr>
-          </a:solidFill>
+        </p:spPr>
+      </p:pic>
+      <p:pic>
+        <p:nvPicPr>
+          <p:cNvPr id="14" name="Picture 13">
+            <a:extLst>
+              <a:ext uri="{FF2B5EF4-FFF2-40B4-BE49-F238E27FC236}">
+                <a16:creationId xmlns:a16="http://schemas.microsoft.com/office/drawing/2014/main" id="{3ABADF14-2E42-23B4-21C7-47F9C010D6D0}"/>
+              </a:ext>
+            </a:extLst>
+          </p:cNvPr>
+          <p:cNvPicPr>
+            <a:picLocks noChangeAspect="1"/>
+          </p:cNvPicPr>
+          <p:nvPr/>
+        </p:nvPicPr>
+        <p:blipFill>
+          <a:blip r:embed="rId5">
+            <a:extLst>
+              <a:ext uri="{28A0092B-C50C-407E-A947-70E740481C1C}">
+                <a14:useLocalDpi xmlns:a14="http://schemas.microsoft.com/office/drawing/2010/main" val="0"/>
+              </a:ext>
+            </a:extLst>
+          </a:blip>
+          <a:stretch>
+            <a:fillRect/>
+          </a:stretch>
+        </p:blipFill>
+        <p:spPr>
+          <a:xfrm>
+            <a:off x="696456" y="1343770"/>
+            <a:ext cx="3599695" cy="2157988"/>
+          </a:xfrm>
+          <a:prstGeom prst="rect">
+            <a:avLst/>
+          </a:prstGeom>
+        </p:spPr>
+      </p:pic>
+      <p:pic>
+        <p:nvPicPr>
+          <p:cNvPr id="16" name="Picture 15">
+            <a:extLst>
+              <a:ext uri="{FF2B5EF4-FFF2-40B4-BE49-F238E27FC236}">
+                <a16:creationId xmlns:a16="http://schemas.microsoft.com/office/drawing/2014/main" id="{90915727-C885-5B49-AA9F-AA07383A0549}"/>
+              </a:ext>
+            </a:extLst>
+          </p:cNvPr>
+          <p:cNvPicPr>
+            <a:picLocks noChangeAspect="1"/>
+          </p:cNvPicPr>
+          <p:nvPr/>
+        </p:nvPicPr>
+        <p:blipFill>
+          <a:blip r:embed="rId6">
+            <a:extLst>
+              <a:ext uri="{28A0092B-C50C-407E-A947-70E740481C1C}">
+                <a14:useLocalDpi xmlns:a14="http://schemas.microsoft.com/office/drawing/2010/main" val="0"/>
+              </a:ext>
+            </a:extLst>
+          </a:blip>
+          <a:stretch>
+            <a:fillRect/>
+          </a:stretch>
+        </p:blipFill>
+        <p:spPr>
+          <a:xfrm>
+            <a:off x="696457" y="4198362"/>
+            <a:ext cx="3599695" cy="2157988"/>
+          </a:xfrm>
+          <a:prstGeom prst="rect">
+            <a:avLst/>
+          </a:prstGeom>
+        </p:spPr>
+      </p:pic>
+      <p:cxnSp>
+        <p:nvCxnSpPr>
+          <p:cNvPr id="18" name="Connector: Curved 17">
+            <a:extLst>
+              <a:ext uri="{FF2B5EF4-FFF2-40B4-BE49-F238E27FC236}">
+                <a16:creationId xmlns:a16="http://schemas.microsoft.com/office/drawing/2014/main" id="{B32DD0CA-28C5-D4BF-95EA-2CDBD7567934}"/>
+              </a:ext>
+            </a:extLst>
+          </p:cNvPr>
+          <p:cNvCxnSpPr>
+            <a:cxnSpLocks/>
+            <a:stCxn id="16" idx="0"/>
+            <a:endCxn id="10" idx="1"/>
+          </p:cNvCxnSpPr>
+          <p:nvPr/>
+        </p:nvCxnSpPr>
+        <p:spPr>
+          <a:xfrm rot="5400000" flipH="1" flipV="1">
+            <a:off x="3230747" y="3103996"/>
+            <a:ext cx="359925" cy="1828809"/>
+          </a:xfrm>
+          <a:prstGeom prst="curvedConnector2">
+            <a:avLst/>
+          </a:prstGeom>
           <a:ln>
-            <a:noFill/>
+            <a:tailEnd type="triangle"/>
           </a:ln>
         </p:spPr>
         <p:style>
           <a:lnRef idx="2">
-            <a:schemeClr val="accent1">
-              <a:shade val="15000"/>
-            </a:schemeClr>
+            <a:schemeClr val="accent1"/>
           </a:lnRef>
-          <a:fillRef idx="1">
+          <a:fillRef idx="0">
             <a:schemeClr val="accent1"/>
           </a:fillRef>
-          <a:effectRef idx="0">
+          <a:effectRef idx="1">
             <a:schemeClr val="accent1"/>
           </a:effectRef>
           <a:fontRef idx="minor">
-            <a:schemeClr val="lt1"/>
+            <a:schemeClr val="tx1"/>
           </a:fontRef>
         </p:style>
-        <p:txBody>
-          <a:bodyPr rtlCol="0" anchor="ctr"/>
-          <a:lstStyle/>
-          <a:p>
-            <a:pPr algn="ctr"/>
-            <a:endParaRPr lang="en-US"/>
-          </a:p>
-        </p:txBody>
-      </p:sp>
+      </p:cxnSp>
+      <p:cxnSp>
+        <p:nvCxnSpPr>
+          <p:cNvPr id="19" name="Connector: Curved 18">
+            <a:extLst>
+              <a:ext uri="{FF2B5EF4-FFF2-40B4-BE49-F238E27FC236}">
+                <a16:creationId xmlns:a16="http://schemas.microsoft.com/office/drawing/2014/main" id="{0080F963-5C70-CCE1-F0C8-011554A691F6}"/>
+              </a:ext>
+            </a:extLst>
+          </p:cNvPr>
+          <p:cNvCxnSpPr>
+            <a:cxnSpLocks/>
+            <a:stCxn id="16" idx="3"/>
+            <a:endCxn id="8" idx="1"/>
+          </p:cNvCxnSpPr>
+          <p:nvPr/>
+        </p:nvCxnSpPr>
+        <p:spPr>
+          <a:xfrm flipV="1">
+            <a:off x="4296152" y="5274052"/>
+            <a:ext cx="3857247" cy="3304"/>
+          </a:xfrm>
+          <a:prstGeom prst="straightConnector1">
+            <a:avLst/>
+          </a:prstGeom>
+          <a:ln>
+            <a:tailEnd type="triangle"/>
+          </a:ln>
+        </p:spPr>
+        <p:style>
+          <a:lnRef idx="2">
+            <a:schemeClr val="accent1"/>
+          </a:lnRef>
+          <a:fillRef idx="0">
+            <a:schemeClr val="accent1"/>
+          </a:fillRef>
+          <a:effectRef idx="1">
+            <a:schemeClr val="accent1"/>
+          </a:effectRef>
+          <a:fontRef idx="minor">
+            <a:schemeClr val="tx1"/>
+          </a:fontRef>
+        </p:style>
+      </p:cxnSp>
+      <mc:AlternateContent xmlns:mc="http://schemas.openxmlformats.org/markup-compatibility/2006">
+        <mc:Choice xmlns:a14="http://schemas.microsoft.com/office/drawing/2010/main" Requires="a14">
+          <p:sp>
+            <p:nvSpPr>
+              <p:cNvPr id="27" name="TextBox 26">
+                <a:extLst>
+                  <a:ext uri="{FF2B5EF4-FFF2-40B4-BE49-F238E27FC236}">
+                    <a16:creationId xmlns:a16="http://schemas.microsoft.com/office/drawing/2014/main" id="{C96F9AAC-0E68-5956-71DB-C00FB1365536}"/>
+                  </a:ext>
+                </a:extLst>
+              </p:cNvPr>
+              <p:cNvSpPr txBox="1"/>
+              <p:nvPr/>
+            </p:nvSpPr>
+            <p:spPr>
+              <a:xfrm>
+                <a:off x="882394" y="3564649"/>
+                <a:ext cx="765018" cy="276999"/>
+              </a:xfrm>
+              <a:prstGeom prst="rect">
+                <a:avLst/>
+              </a:prstGeom>
+              <a:noFill/>
+            </p:spPr>
+            <p:txBody>
+              <a:bodyPr wrap="none" lIns="0" tIns="0" rIns="0" bIns="0" rtlCol="0">
+                <a:spAutoFit/>
+              </a:bodyPr>
+              <a:lstStyle/>
+              <a:p>
+                <a14:m>
+                  <m:oMathPara xmlns:m="http://schemas.openxmlformats.org/officeDocument/2006/math">
+                    <m:oMathParaPr>
+                      <m:jc m:val="centerGroup"/>
+                    </m:oMathParaPr>
+                    <m:oMath xmlns:m="http://schemas.openxmlformats.org/officeDocument/2006/math">
+                      <m:r>
+                        <a:rPr lang="en-SE" b="0" i="1" smtClean="0">
+                          <a:latin typeface="Cambria Math" panose="02040503050406030204" pitchFamily="18" charset="0"/>
+                        </a:rPr>
+                        <m:t>𝜇</m:t>
+                      </m:r>
+                      <m:r>
+                        <a:rPr lang="en-SE" b="0" i="1" smtClean="0">
+                          <a:latin typeface="Cambria Math" panose="02040503050406030204" pitchFamily="18" charset="0"/>
+                        </a:rPr>
+                        <m:t>=</m:t>
+                      </m:r>
+                      <m:r>
+                        <a:rPr lang="en-SE" b="0" i="1" smtClean="0">
+                          <a:latin typeface="Cambria Math" panose="02040503050406030204" pitchFamily="18" charset="0"/>
+                        </a:rPr>
+                        <m:t>𝛼𝛽</m:t>
+                      </m:r>
+                    </m:oMath>
+                  </m:oMathPara>
+                </a14:m>
+                <a:endParaRPr lang="en-SE" dirty="0"/>
+              </a:p>
+            </p:txBody>
+          </p:sp>
+        </mc:Choice>
+        <mc:Fallback>
+          <p:sp>
+            <p:nvSpPr>
+              <p:cNvPr id="27" name="TextBox 26">
+                <a:extLst>
+                  <a:ext uri="{FF2B5EF4-FFF2-40B4-BE49-F238E27FC236}">
+                    <a16:creationId xmlns:a16="http://schemas.microsoft.com/office/drawing/2014/main" id="{C96F9AAC-0E68-5956-71DB-C00FB1365536}"/>
+                  </a:ext>
+                </a:extLst>
+              </p:cNvPr>
+              <p:cNvSpPr txBox="1">
+                <a:spLocks noRot="1" noChangeAspect="1" noMove="1" noResize="1" noEditPoints="1" noAdjustHandles="1" noChangeArrowheads="1" noChangeShapeType="1" noTextEdit="1"/>
+              </p:cNvSpPr>
+              <p:nvPr/>
+            </p:nvSpPr>
+            <p:spPr>
+              <a:xfrm>
+                <a:off x="882394" y="3564649"/>
+                <a:ext cx="765018" cy="276999"/>
+              </a:xfrm>
+              <a:prstGeom prst="rect">
+                <a:avLst/>
+              </a:prstGeom>
+              <a:blipFill>
+                <a:blip r:embed="rId7"/>
+                <a:stretch>
+                  <a:fillRect l="-8000" t="-2222" r="-11200" b="-35556"/>
+                </a:stretch>
+              </a:blipFill>
+            </p:spPr>
+            <p:txBody>
+              <a:bodyPr/>
+              <a:lstStyle/>
+              <a:p>
+                <a:r>
+                  <a:rPr lang="en-SE">
+                    <a:noFill/>
+                  </a:rPr>
+                  <a:t> </a:t>
+                </a:r>
+              </a:p>
+            </p:txBody>
+          </p:sp>
+        </mc:Fallback>
+      </mc:AlternateContent>
+      <mc:AlternateContent xmlns:mc="http://schemas.openxmlformats.org/markup-compatibility/2006">
+        <mc:Choice xmlns:a14="http://schemas.microsoft.com/office/drawing/2010/main" Requires="a14">
+          <p:sp>
+            <p:nvSpPr>
+              <p:cNvPr id="31" name="TextBox 30">
+                <a:extLst>
+                  <a:ext uri="{FF2B5EF4-FFF2-40B4-BE49-F238E27FC236}">
+                    <a16:creationId xmlns:a16="http://schemas.microsoft.com/office/drawing/2014/main" id="{FB84052B-DE2A-90E2-CD9C-9BDF668DEB78}"/>
+                  </a:ext>
+                </a:extLst>
+              </p:cNvPr>
+              <p:cNvSpPr txBox="1"/>
+              <p:nvPr/>
+            </p:nvSpPr>
+            <p:spPr>
+              <a:xfrm>
+                <a:off x="1871242" y="3564649"/>
+                <a:ext cx="1006494" cy="276999"/>
+              </a:xfrm>
+              <a:prstGeom prst="rect">
+                <a:avLst/>
+              </a:prstGeom>
+              <a:noFill/>
+            </p:spPr>
+            <p:txBody>
+              <a:bodyPr wrap="none" lIns="0" tIns="0" rIns="0" bIns="0" rtlCol="0">
+                <a:spAutoFit/>
+              </a:bodyPr>
+              <a:lstStyle/>
+              <a:p>
+                <a14:m>
+                  <m:oMathPara xmlns:m="http://schemas.openxmlformats.org/officeDocument/2006/math">
+                    <m:oMathParaPr>
+                      <m:jc m:val="centerGroup"/>
+                    </m:oMathParaPr>
+                    <m:oMath xmlns:m="http://schemas.openxmlformats.org/officeDocument/2006/math">
+                      <m:sSup>
+                        <m:sSupPr>
+                          <m:ctrlPr>
+                            <a:rPr lang="en-SE" b="0" i="1" smtClean="0">
+                              <a:latin typeface="Cambria Math" panose="02040503050406030204" pitchFamily="18" charset="0"/>
+                            </a:rPr>
+                          </m:ctrlPr>
+                        </m:sSupPr>
+                        <m:e>
+                          <m:r>
+                            <a:rPr lang="en-SE" b="0" i="1" smtClean="0">
+                              <a:latin typeface="Cambria Math" panose="02040503050406030204" pitchFamily="18" charset="0"/>
+                            </a:rPr>
+                            <m:t>𝜎</m:t>
+                          </m:r>
+                        </m:e>
+                        <m:sup>
+                          <m:r>
+                            <a:rPr lang="en-SE" b="0" i="1" smtClean="0">
+                              <a:latin typeface="Cambria Math" panose="02040503050406030204" pitchFamily="18" charset="0"/>
+                            </a:rPr>
+                            <m:t>2</m:t>
+                          </m:r>
+                        </m:sup>
+                      </m:sSup>
+                      <m:r>
+                        <a:rPr lang="en-SE" b="0" i="1" smtClean="0">
+                          <a:latin typeface="Cambria Math" panose="02040503050406030204" pitchFamily="18" charset="0"/>
+                        </a:rPr>
+                        <m:t>=</m:t>
+                      </m:r>
+                      <m:sSup>
+                        <m:sSupPr>
+                          <m:ctrlPr>
+                            <a:rPr lang="en-SE" b="0" i="1" smtClean="0">
+                              <a:latin typeface="Cambria Math" panose="02040503050406030204" pitchFamily="18" charset="0"/>
+                            </a:rPr>
+                          </m:ctrlPr>
+                        </m:sSupPr>
+                        <m:e>
+                          <m:r>
+                            <a:rPr lang="en-SE" b="0" i="1" smtClean="0">
+                              <a:latin typeface="Cambria Math" panose="02040503050406030204" pitchFamily="18" charset="0"/>
+                            </a:rPr>
+                            <m:t>𝛼</m:t>
+                          </m:r>
+                        </m:e>
+                        <m:sup>
+                          <m:r>
+                            <a:rPr lang="en-SE" b="0" i="1" smtClean="0">
+                              <a:latin typeface="Cambria Math" panose="02040503050406030204" pitchFamily="18" charset="0"/>
+                            </a:rPr>
+                            <m:t>2</m:t>
+                          </m:r>
+                        </m:sup>
+                      </m:sSup>
+                      <m:r>
+                        <a:rPr lang="en-SE" b="0" i="1" smtClean="0">
+                          <a:latin typeface="Cambria Math" panose="02040503050406030204" pitchFamily="18" charset="0"/>
+                        </a:rPr>
+                        <m:t>𝛽</m:t>
+                      </m:r>
+                    </m:oMath>
+                  </m:oMathPara>
+                </a14:m>
+                <a:endParaRPr lang="en-SE" dirty="0"/>
+              </a:p>
+            </p:txBody>
+          </p:sp>
+        </mc:Choice>
+        <mc:Fallback>
+          <p:sp>
+            <p:nvSpPr>
+              <p:cNvPr id="31" name="TextBox 30">
+                <a:extLst>
+                  <a:ext uri="{FF2B5EF4-FFF2-40B4-BE49-F238E27FC236}">
+                    <a16:creationId xmlns:a16="http://schemas.microsoft.com/office/drawing/2014/main" id="{FB84052B-DE2A-90E2-CD9C-9BDF668DEB78}"/>
+                  </a:ext>
+                </a:extLst>
+              </p:cNvPr>
+              <p:cNvSpPr txBox="1">
+                <a:spLocks noRot="1" noChangeAspect="1" noMove="1" noResize="1" noEditPoints="1" noAdjustHandles="1" noChangeArrowheads="1" noChangeShapeType="1" noTextEdit="1"/>
+              </p:cNvSpPr>
+              <p:nvPr/>
+            </p:nvSpPr>
+            <p:spPr>
+              <a:xfrm>
+                <a:off x="1871242" y="3564649"/>
+                <a:ext cx="1006494" cy="276999"/>
+              </a:xfrm>
+              <a:prstGeom prst="rect">
+                <a:avLst/>
+              </a:prstGeom>
+              <a:blipFill>
+                <a:blip r:embed="rId8"/>
+                <a:stretch>
+                  <a:fillRect l="-3030" t="-2222" r="-7879" b="-35556"/>
+                </a:stretch>
+              </a:blipFill>
+            </p:spPr>
+            <p:txBody>
+              <a:bodyPr/>
+              <a:lstStyle/>
+              <a:p>
+                <a:r>
+                  <a:rPr lang="en-SE">
+                    <a:noFill/>
+                  </a:rPr>
+                  <a:t> </a:t>
+                </a:r>
+              </a:p>
+            </p:txBody>
+          </p:sp>
+        </mc:Fallback>
+      </mc:AlternateContent>
+      <mc:AlternateContent xmlns:mc="http://schemas.openxmlformats.org/markup-compatibility/2006">
+        <mc:Choice xmlns:a14="http://schemas.microsoft.com/office/drawing/2010/main" Requires="a14">
+          <p:sp>
+            <p:nvSpPr>
+              <p:cNvPr id="32" name="TextBox 31">
+                <a:extLst>
+                  <a:ext uri="{FF2B5EF4-FFF2-40B4-BE49-F238E27FC236}">
+                    <a16:creationId xmlns:a16="http://schemas.microsoft.com/office/drawing/2014/main" id="{3BDADB41-FE2D-3FB4-4918-E8729E3205C1}"/>
+                  </a:ext>
+                </a:extLst>
+              </p:cNvPr>
+              <p:cNvSpPr txBox="1"/>
+              <p:nvPr/>
+            </p:nvSpPr>
+            <p:spPr>
+              <a:xfrm>
+                <a:off x="3078153" y="3564649"/>
+                <a:ext cx="710707" cy="276999"/>
+              </a:xfrm>
+              <a:prstGeom prst="rect">
+                <a:avLst/>
+              </a:prstGeom>
+              <a:noFill/>
+            </p:spPr>
+            <p:txBody>
+              <a:bodyPr wrap="none" lIns="0" tIns="0" rIns="0" bIns="0" rtlCol="0">
+                <a:spAutoFit/>
+              </a:bodyPr>
+              <a:lstStyle/>
+              <a:p>
+                <a14:m>
+                  <m:oMathPara xmlns:m="http://schemas.openxmlformats.org/officeDocument/2006/math">
+                    <m:oMathParaPr>
+                      <m:jc m:val="centerGroup"/>
+                    </m:oMathParaPr>
+                    <m:oMath xmlns:m="http://schemas.openxmlformats.org/officeDocument/2006/math">
+                      <m:r>
+                        <a:rPr lang="en-SE" b="0" i="1" smtClean="0">
+                          <a:latin typeface="Cambria Math" panose="02040503050406030204" pitchFamily="18" charset="0"/>
+                        </a:rPr>
+                        <m:t>𝛽</m:t>
+                      </m:r>
+                      <m:r>
+                        <a:rPr lang="en-SE" b="0" i="1" smtClean="0">
+                          <a:latin typeface="Cambria Math" panose="02040503050406030204" pitchFamily="18" charset="0"/>
+                        </a:rPr>
+                        <m:t>→∞</m:t>
+                      </m:r>
+                    </m:oMath>
+                  </m:oMathPara>
+                </a14:m>
+                <a:endParaRPr lang="en-SE" dirty="0"/>
+              </a:p>
+            </p:txBody>
+          </p:sp>
+        </mc:Choice>
+        <mc:Fallback>
+          <p:sp>
+            <p:nvSpPr>
+              <p:cNvPr id="32" name="TextBox 31">
+                <a:extLst>
+                  <a:ext uri="{FF2B5EF4-FFF2-40B4-BE49-F238E27FC236}">
+                    <a16:creationId xmlns:a16="http://schemas.microsoft.com/office/drawing/2014/main" id="{3BDADB41-FE2D-3FB4-4918-E8729E3205C1}"/>
+                  </a:ext>
+                </a:extLst>
+              </p:cNvPr>
+              <p:cNvSpPr txBox="1">
+                <a:spLocks noRot="1" noChangeAspect="1" noMove="1" noResize="1" noEditPoints="1" noAdjustHandles="1" noChangeArrowheads="1" noChangeShapeType="1" noTextEdit="1"/>
+              </p:cNvSpPr>
+              <p:nvPr/>
+            </p:nvSpPr>
+            <p:spPr>
+              <a:xfrm>
+                <a:off x="3078153" y="3564649"/>
+                <a:ext cx="710707" cy="276999"/>
+              </a:xfrm>
+              <a:prstGeom prst="rect">
+                <a:avLst/>
+              </a:prstGeom>
+              <a:blipFill>
+                <a:blip r:embed="rId9"/>
+                <a:stretch>
+                  <a:fillRect l="-11966" t="-2222" r="-3419" b="-35556"/>
+                </a:stretch>
+              </a:blipFill>
+            </p:spPr>
+            <p:txBody>
+              <a:bodyPr/>
+              <a:lstStyle/>
+              <a:p>
+                <a:r>
+                  <a:rPr lang="en-SE">
+                    <a:noFill/>
+                  </a:rPr>
+                  <a:t> </a:t>
+                </a:r>
+              </a:p>
+            </p:txBody>
+          </p:sp>
+        </mc:Fallback>
+      </mc:AlternateContent>
+      <mc:AlternateContent xmlns:mc="http://schemas.openxmlformats.org/markup-compatibility/2006">
+        <mc:Choice xmlns:a14="http://schemas.microsoft.com/office/drawing/2010/main" Requires="a14">
+          <p:sp>
+            <p:nvSpPr>
+              <p:cNvPr id="33" name="TextBox 32">
+                <a:extLst>
+                  <a:ext uri="{FF2B5EF4-FFF2-40B4-BE49-F238E27FC236}">
+                    <a16:creationId xmlns:a16="http://schemas.microsoft.com/office/drawing/2014/main" id="{DDDB7B86-50FD-371D-24C7-0C45EDA10CD9}"/>
+                  </a:ext>
+                </a:extLst>
+              </p:cNvPr>
+              <p:cNvSpPr txBox="1"/>
+              <p:nvPr/>
+            </p:nvSpPr>
+            <p:spPr>
+              <a:xfrm>
+                <a:off x="5665625" y="5357945"/>
+                <a:ext cx="860748" cy="563872"/>
+              </a:xfrm>
+              <a:prstGeom prst="rect">
+                <a:avLst/>
+              </a:prstGeom>
+              <a:noFill/>
+            </p:spPr>
+            <p:txBody>
+              <a:bodyPr wrap="none" lIns="0" tIns="0" rIns="0" bIns="0" rtlCol="0">
+                <a:spAutoFit/>
+              </a:bodyPr>
+              <a:lstStyle/>
+              <a:p>
+                <a14:m>
+                  <m:oMathPara xmlns:m="http://schemas.openxmlformats.org/officeDocument/2006/math">
+                    <m:oMathParaPr>
+                      <m:jc m:val="centerGroup"/>
+                    </m:oMathParaPr>
+                    <m:oMath xmlns:m="http://schemas.openxmlformats.org/officeDocument/2006/math">
+                      <m:r>
+                        <a:rPr lang="en-SE" b="0" i="1" smtClean="0">
+                          <a:latin typeface="Cambria Math" panose="02040503050406030204" pitchFamily="18" charset="0"/>
+                        </a:rPr>
+                        <m:t> </m:t>
+                      </m:r>
+                      <m:f>
+                        <m:fPr>
+                          <m:ctrlPr>
+                            <a:rPr lang="en-SE" b="0" i="1" smtClean="0">
+                              <a:latin typeface="Cambria Math" panose="02040503050406030204" pitchFamily="18" charset="0"/>
+                            </a:rPr>
+                          </m:ctrlPr>
+                        </m:fPr>
+                        <m:num>
+                          <m:sSub>
+                            <m:sSubPr>
+                              <m:ctrlPr>
+                                <a:rPr lang="en-SE" b="0" i="1" smtClean="0">
+                                  <a:latin typeface="Cambria Math" panose="02040503050406030204" pitchFamily="18" charset="0"/>
+                                </a:rPr>
+                              </m:ctrlPr>
+                            </m:sSubPr>
+                            <m:e>
+                              <m:r>
+                                <a:rPr lang="en-SE" b="0" i="1" smtClean="0">
+                                  <a:latin typeface="Cambria Math" panose="02040503050406030204" pitchFamily="18" charset="0"/>
+                                </a:rPr>
+                                <m:t>𝑋</m:t>
+                              </m:r>
+                            </m:e>
+                            <m:sub>
+                              <m:r>
+                                <a:rPr lang="en-SE" b="0" i="1" smtClean="0">
+                                  <a:latin typeface="Cambria Math" panose="02040503050406030204" pitchFamily="18" charset="0"/>
+                                </a:rPr>
+                                <m:t>1</m:t>
+                              </m:r>
+                            </m:sub>
+                          </m:sSub>
+                        </m:num>
+                        <m:den>
+                          <m:sSub>
+                            <m:sSubPr>
+                              <m:ctrlPr>
+                                <a:rPr lang="en-SE" b="0" i="1" smtClean="0">
+                                  <a:latin typeface="Cambria Math" panose="02040503050406030204" pitchFamily="18" charset="0"/>
+                                </a:rPr>
+                              </m:ctrlPr>
+                            </m:sSubPr>
+                            <m:e>
+                              <m:r>
+                                <a:rPr lang="en-SE" b="0" i="1" smtClean="0">
+                                  <a:latin typeface="Cambria Math" panose="02040503050406030204" pitchFamily="18" charset="0"/>
+                                </a:rPr>
+                                <m:t>𝑋</m:t>
+                              </m:r>
+                            </m:e>
+                            <m:sub>
+                              <m:r>
+                                <a:rPr lang="en-SE" b="0" i="1" smtClean="0">
+                                  <a:latin typeface="Cambria Math" panose="02040503050406030204" pitchFamily="18" charset="0"/>
+                                </a:rPr>
+                                <m:t>1</m:t>
+                              </m:r>
+                            </m:sub>
+                          </m:sSub>
+                          <m:r>
+                            <a:rPr lang="en-SE" b="0" i="1" smtClean="0">
+                              <a:latin typeface="Cambria Math" panose="02040503050406030204" pitchFamily="18" charset="0"/>
+                            </a:rPr>
+                            <m:t>+</m:t>
+                          </m:r>
+                          <m:sSub>
+                            <m:sSubPr>
+                              <m:ctrlPr>
+                                <a:rPr lang="en-SE" b="0" i="1" smtClean="0">
+                                  <a:latin typeface="Cambria Math" panose="02040503050406030204" pitchFamily="18" charset="0"/>
+                                </a:rPr>
+                              </m:ctrlPr>
+                            </m:sSubPr>
+                            <m:e>
+                              <m:r>
+                                <a:rPr lang="en-SE" b="0" i="1" smtClean="0">
+                                  <a:latin typeface="Cambria Math" panose="02040503050406030204" pitchFamily="18" charset="0"/>
+                                </a:rPr>
+                                <m:t>𝑋</m:t>
+                              </m:r>
+                            </m:e>
+                            <m:sub>
+                              <m:r>
+                                <a:rPr lang="en-SE" b="0" i="1" smtClean="0">
+                                  <a:latin typeface="Cambria Math" panose="02040503050406030204" pitchFamily="18" charset="0"/>
+                                </a:rPr>
+                                <m:t>2</m:t>
+                              </m:r>
+                            </m:sub>
+                          </m:sSub>
+                        </m:den>
+                      </m:f>
+                    </m:oMath>
+                  </m:oMathPara>
+                </a14:m>
+                <a:endParaRPr lang="en-SE" dirty="0"/>
+              </a:p>
+            </p:txBody>
+          </p:sp>
+        </mc:Choice>
+        <mc:Fallback>
+          <p:sp>
+            <p:nvSpPr>
+              <p:cNvPr id="33" name="TextBox 32">
+                <a:extLst>
+                  <a:ext uri="{FF2B5EF4-FFF2-40B4-BE49-F238E27FC236}">
+                    <a16:creationId xmlns:a16="http://schemas.microsoft.com/office/drawing/2014/main" id="{DDDB7B86-50FD-371D-24C7-0C45EDA10CD9}"/>
+                  </a:ext>
+                </a:extLst>
+              </p:cNvPr>
+              <p:cNvSpPr txBox="1">
+                <a:spLocks noRot="1" noChangeAspect="1" noMove="1" noResize="1" noEditPoints="1" noAdjustHandles="1" noChangeArrowheads="1" noChangeShapeType="1" noTextEdit="1"/>
+              </p:cNvSpPr>
+              <p:nvPr/>
+            </p:nvSpPr>
+            <p:spPr>
+              <a:xfrm>
+                <a:off x="5665625" y="5357945"/>
+                <a:ext cx="860748" cy="563872"/>
+              </a:xfrm>
+              <a:prstGeom prst="rect">
+                <a:avLst/>
+              </a:prstGeom>
+              <a:blipFill>
+                <a:blip r:embed="rId10"/>
+                <a:stretch>
+                  <a:fillRect/>
+                </a:stretch>
+              </a:blipFill>
+            </p:spPr>
+            <p:txBody>
+              <a:bodyPr/>
+              <a:lstStyle/>
+              <a:p>
+                <a:r>
+                  <a:rPr lang="en-SE">
+                    <a:noFill/>
+                  </a:rPr>
+                  <a:t> </a:t>
+                </a:r>
+              </a:p>
+            </p:txBody>
+          </p:sp>
+        </mc:Fallback>
+      </mc:AlternateContent>
+      <p:cxnSp>
+        <p:nvCxnSpPr>
+          <p:cNvPr id="36" name="Connector: Curved 35">
+            <a:extLst>
+              <a:ext uri="{FF2B5EF4-FFF2-40B4-BE49-F238E27FC236}">
+                <a16:creationId xmlns:a16="http://schemas.microsoft.com/office/drawing/2014/main" id="{98E4B3AD-9BF9-E0DC-241D-130C6257E4C4}"/>
+              </a:ext>
+            </a:extLst>
+          </p:cNvPr>
+          <p:cNvCxnSpPr>
+            <a:cxnSpLocks/>
+            <a:stCxn id="14" idx="3"/>
+            <a:endCxn id="10" idx="0"/>
+          </p:cNvCxnSpPr>
+          <p:nvPr/>
+        </p:nvCxnSpPr>
+        <p:spPr>
+          <a:xfrm>
+            <a:off x="4296151" y="2422764"/>
+            <a:ext cx="1828811" cy="336679"/>
+          </a:xfrm>
+          <a:prstGeom prst="curvedConnector2">
+            <a:avLst/>
+          </a:prstGeom>
+          <a:ln>
+            <a:tailEnd type="triangle"/>
+          </a:ln>
+        </p:spPr>
+        <p:style>
+          <a:lnRef idx="2">
+            <a:schemeClr val="accent1"/>
+          </a:lnRef>
+          <a:fillRef idx="0">
+            <a:schemeClr val="accent1"/>
+          </a:fillRef>
+          <a:effectRef idx="1">
+            <a:schemeClr val="accent1"/>
+          </a:effectRef>
+          <a:fontRef idx="minor">
+            <a:schemeClr val="tx1"/>
+          </a:fontRef>
+        </p:style>
+      </p:cxnSp>
+      <mc:AlternateContent xmlns:mc="http://schemas.openxmlformats.org/markup-compatibility/2006">
+        <mc:Choice xmlns:a14="http://schemas.microsoft.com/office/drawing/2010/main" Requires="a14">
+          <p:sp>
+            <p:nvSpPr>
+              <p:cNvPr id="39" name="TextBox 38">
+                <a:extLst>
+                  <a:ext uri="{FF2B5EF4-FFF2-40B4-BE49-F238E27FC236}">
+                    <a16:creationId xmlns:a16="http://schemas.microsoft.com/office/drawing/2014/main" id="{E22F4B23-ECD0-4B88-5C5D-A793E5BE2D39}"/>
+                  </a:ext>
+                </a:extLst>
+              </p:cNvPr>
+              <p:cNvSpPr txBox="1"/>
+              <p:nvPr/>
+            </p:nvSpPr>
+            <p:spPr>
+              <a:xfrm>
+                <a:off x="4524742" y="2105954"/>
+                <a:ext cx="736227" cy="276999"/>
+              </a:xfrm>
+              <a:prstGeom prst="rect">
+                <a:avLst/>
+              </a:prstGeom>
+              <a:noFill/>
+            </p:spPr>
+            <p:txBody>
+              <a:bodyPr wrap="none" lIns="0" tIns="0" rIns="0" bIns="0" rtlCol="0">
+                <a:spAutoFit/>
+              </a:bodyPr>
+              <a:lstStyle/>
+              <a:p>
+                <a14:m>
+                  <m:oMathPara xmlns:m="http://schemas.openxmlformats.org/officeDocument/2006/math">
+                    <m:oMathParaPr>
+                      <m:jc m:val="centerGroup"/>
+                    </m:oMathParaPr>
+                    <m:oMath xmlns:m="http://schemas.openxmlformats.org/officeDocument/2006/math">
+                      <m:sSup>
+                        <m:sSupPr>
+                          <m:ctrlPr>
+                            <a:rPr lang="en-SE" b="0" i="1" smtClean="0">
+                              <a:latin typeface="Cambria Math" panose="02040503050406030204" pitchFamily="18" charset="0"/>
+                            </a:rPr>
+                          </m:ctrlPr>
+                        </m:sSupPr>
+                        <m:e>
+                          <m:r>
+                            <a:rPr lang="en-SE" b="0" i="1" smtClean="0">
+                              <a:latin typeface="Cambria Math" panose="02040503050406030204" pitchFamily="18" charset="0"/>
+                            </a:rPr>
+                            <m:t>𝜎</m:t>
+                          </m:r>
+                        </m:e>
+                        <m:sup>
+                          <m:r>
+                            <a:rPr lang="en-SE" b="0" i="1" smtClean="0">
+                              <a:latin typeface="Cambria Math" panose="02040503050406030204" pitchFamily="18" charset="0"/>
+                            </a:rPr>
+                            <m:t>2</m:t>
+                          </m:r>
+                        </m:sup>
+                      </m:sSup>
+                      <m:r>
+                        <a:rPr lang="en-SE" b="0" i="1" smtClean="0">
+                          <a:latin typeface="Cambria Math" panose="02040503050406030204" pitchFamily="18" charset="0"/>
+                        </a:rPr>
+                        <m:t>=</m:t>
+                      </m:r>
+                      <m:r>
+                        <a:rPr lang="en-SE" b="0" i="1" smtClean="0">
+                          <a:latin typeface="Cambria Math" panose="02040503050406030204" pitchFamily="18" charset="0"/>
+                        </a:rPr>
+                        <m:t>𝜇</m:t>
+                      </m:r>
+                    </m:oMath>
+                  </m:oMathPara>
+                </a14:m>
+                <a:endParaRPr lang="en-SE" dirty="0"/>
+              </a:p>
+            </p:txBody>
+          </p:sp>
+        </mc:Choice>
+        <mc:Fallback>
+          <p:sp>
+            <p:nvSpPr>
+              <p:cNvPr id="39" name="TextBox 38">
+                <a:extLst>
+                  <a:ext uri="{FF2B5EF4-FFF2-40B4-BE49-F238E27FC236}">
+                    <a16:creationId xmlns:a16="http://schemas.microsoft.com/office/drawing/2014/main" id="{E22F4B23-ECD0-4B88-5C5D-A793E5BE2D39}"/>
+                  </a:ext>
+                </a:extLst>
+              </p:cNvPr>
+              <p:cNvSpPr txBox="1">
+                <a:spLocks noRot="1" noChangeAspect="1" noMove="1" noResize="1" noEditPoints="1" noAdjustHandles="1" noChangeArrowheads="1" noChangeShapeType="1" noTextEdit="1"/>
+              </p:cNvSpPr>
+              <p:nvPr/>
+            </p:nvSpPr>
+            <p:spPr>
+              <a:xfrm>
+                <a:off x="4524742" y="2105954"/>
+                <a:ext cx="736227" cy="276999"/>
+              </a:xfrm>
+              <a:prstGeom prst="rect">
+                <a:avLst/>
+              </a:prstGeom>
+              <a:blipFill>
+                <a:blip r:embed="rId11"/>
+                <a:stretch>
+                  <a:fillRect l="-4959" r="-7438" b="-21739"/>
+                </a:stretch>
+              </a:blipFill>
+            </p:spPr>
+            <p:txBody>
+              <a:bodyPr/>
+              <a:lstStyle/>
+              <a:p>
+                <a:r>
+                  <a:rPr lang="en-SE">
+                    <a:noFill/>
+                  </a:rPr>
+                  <a:t> </a:t>
+                </a:r>
+              </a:p>
+            </p:txBody>
+          </p:sp>
+        </mc:Fallback>
+      </mc:AlternateContent>
+      <mc:AlternateContent xmlns:mc="http://schemas.openxmlformats.org/markup-compatibility/2006">
+        <mc:Choice xmlns:a14="http://schemas.microsoft.com/office/drawing/2010/main" Requires="a14">
+          <p:sp>
+            <p:nvSpPr>
+              <p:cNvPr id="40" name="TextBox 39">
+                <a:extLst>
+                  <a:ext uri="{FF2B5EF4-FFF2-40B4-BE49-F238E27FC236}">
+                    <a16:creationId xmlns:a16="http://schemas.microsoft.com/office/drawing/2014/main" id="{D4D57EBA-75E7-E783-9102-AAF82063A468}"/>
+                  </a:ext>
+                </a:extLst>
+              </p:cNvPr>
+              <p:cNvSpPr txBox="1"/>
+              <p:nvPr/>
+            </p:nvSpPr>
+            <p:spPr>
+              <a:xfrm>
+                <a:off x="4543947" y="2492682"/>
+                <a:ext cx="697114" cy="276999"/>
+              </a:xfrm>
+              <a:prstGeom prst="rect">
+                <a:avLst/>
+              </a:prstGeom>
+              <a:noFill/>
+            </p:spPr>
+            <p:txBody>
+              <a:bodyPr wrap="none" lIns="0" tIns="0" rIns="0" bIns="0" rtlCol="0">
+                <a:spAutoFit/>
+              </a:bodyPr>
+              <a:lstStyle/>
+              <a:p>
+                <a14:m>
+                  <m:oMathPara xmlns:m="http://schemas.openxmlformats.org/officeDocument/2006/math">
+                    <m:oMathParaPr>
+                      <m:jc m:val="centerGroup"/>
+                    </m:oMathParaPr>
+                    <m:oMath xmlns:m="http://schemas.openxmlformats.org/officeDocument/2006/math">
+                      <m:r>
+                        <a:rPr lang="en-SE" b="0" i="1" smtClean="0">
+                          <a:latin typeface="Cambria Math" panose="02040503050406030204" pitchFamily="18" charset="0"/>
+                        </a:rPr>
+                        <m:t>𝜇</m:t>
+                      </m:r>
+                      <m:r>
+                        <a:rPr lang="en-SE" b="0" i="1" smtClean="0">
+                          <a:latin typeface="Cambria Math" panose="02040503050406030204" pitchFamily="18" charset="0"/>
+                        </a:rPr>
+                        <m:t>→∞</m:t>
+                      </m:r>
+                    </m:oMath>
+                  </m:oMathPara>
+                </a14:m>
+                <a:endParaRPr lang="en-SE" dirty="0"/>
+              </a:p>
+            </p:txBody>
+          </p:sp>
+        </mc:Choice>
+        <mc:Fallback>
+          <p:sp>
+            <p:nvSpPr>
+              <p:cNvPr id="40" name="TextBox 39">
+                <a:extLst>
+                  <a:ext uri="{FF2B5EF4-FFF2-40B4-BE49-F238E27FC236}">
+                    <a16:creationId xmlns:a16="http://schemas.microsoft.com/office/drawing/2014/main" id="{D4D57EBA-75E7-E783-9102-AAF82063A468}"/>
+                  </a:ext>
+                </a:extLst>
+              </p:cNvPr>
+              <p:cNvSpPr txBox="1">
+                <a:spLocks noRot="1" noChangeAspect="1" noMove="1" noResize="1" noEditPoints="1" noAdjustHandles="1" noChangeArrowheads="1" noChangeShapeType="1" noTextEdit="1"/>
+              </p:cNvSpPr>
+              <p:nvPr/>
+            </p:nvSpPr>
+            <p:spPr>
+              <a:xfrm>
+                <a:off x="4543947" y="2492682"/>
+                <a:ext cx="697114" cy="276999"/>
+              </a:xfrm>
+              <a:prstGeom prst="rect">
+                <a:avLst/>
+              </a:prstGeom>
+              <a:blipFill>
+                <a:blip r:embed="rId12"/>
+                <a:stretch>
+                  <a:fillRect l="-7826" r="-4348" b="-22222"/>
+                </a:stretch>
+              </a:blipFill>
+            </p:spPr>
+            <p:txBody>
+              <a:bodyPr/>
+              <a:lstStyle/>
+              <a:p>
+                <a:r>
+                  <a:rPr lang="en-SE">
+                    <a:noFill/>
+                  </a:rPr>
+                  <a:t> </a:t>
+                </a:r>
+              </a:p>
+            </p:txBody>
+          </p:sp>
+        </mc:Fallback>
+      </mc:AlternateContent>
+      <p:cxnSp>
+        <p:nvCxnSpPr>
+          <p:cNvPr id="41" name="Connector: Curved 40">
+            <a:extLst>
+              <a:ext uri="{FF2B5EF4-FFF2-40B4-BE49-F238E27FC236}">
+                <a16:creationId xmlns:a16="http://schemas.microsoft.com/office/drawing/2014/main" id="{70E5BE7E-7294-251D-AEA9-162608829A44}"/>
+              </a:ext>
+            </a:extLst>
+          </p:cNvPr>
+          <p:cNvCxnSpPr>
+            <a:cxnSpLocks/>
+            <a:stCxn id="12" idx="1"/>
+            <a:endCxn id="10" idx="0"/>
+          </p:cNvCxnSpPr>
+          <p:nvPr/>
+        </p:nvCxnSpPr>
+        <p:spPr>
+          <a:xfrm rot="10800000" flipV="1">
+            <a:off x="6124962" y="2422763"/>
+            <a:ext cx="2028438" cy="336679"/>
+          </a:xfrm>
+          <a:prstGeom prst="curvedConnector2">
+            <a:avLst/>
+          </a:prstGeom>
+          <a:ln>
+            <a:tailEnd type="triangle"/>
+          </a:ln>
+        </p:spPr>
+        <p:style>
+          <a:lnRef idx="2">
+            <a:schemeClr val="accent1"/>
+          </a:lnRef>
+          <a:fillRef idx="0">
+            <a:schemeClr val="accent1"/>
+          </a:fillRef>
+          <a:effectRef idx="1">
+            <a:schemeClr val="accent1"/>
+          </a:effectRef>
+          <a:fontRef idx="minor">
+            <a:schemeClr val="tx1"/>
+          </a:fontRef>
+        </p:style>
+      </p:cxnSp>
+      <mc:AlternateContent xmlns:mc="http://schemas.openxmlformats.org/markup-compatibility/2006">
+        <mc:Choice xmlns:a14="http://schemas.microsoft.com/office/drawing/2010/main" Requires="a14">
+          <p:sp>
+            <p:nvSpPr>
+              <p:cNvPr id="45" name="TextBox 44">
+                <a:extLst>
+                  <a:ext uri="{FF2B5EF4-FFF2-40B4-BE49-F238E27FC236}">
+                    <a16:creationId xmlns:a16="http://schemas.microsoft.com/office/drawing/2014/main" id="{1C7CAFF0-31CB-C8C7-53F7-A475F6453CF6}"/>
+                  </a:ext>
+                </a:extLst>
+              </p:cNvPr>
+              <p:cNvSpPr txBox="1"/>
+              <p:nvPr/>
+            </p:nvSpPr>
+            <p:spPr>
+              <a:xfrm>
+                <a:off x="7302877" y="2076632"/>
+                <a:ext cx="744819" cy="276999"/>
+              </a:xfrm>
+              <a:prstGeom prst="rect">
+                <a:avLst/>
+              </a:prstGeom>
+              <a:noFill/>
+            </p:spPr>
+            <p:txBody>
+              <a:bodyPr wrap="none" lIns="0" tIns="0" rIns="0" bIns="0" rtlCol="0">
+                <a:spAutoFit/>
+              </a:bodyPr>
+              <a:lstStyle/>
+              <a:p>
+                <a14:m>
+                  <m:oMathPara xmlns:m="http://schemas.openxmlformats.org/officeDocument/2006/math">
+                    <m:oMathParaPr>
+                      <m:jc m:val="centerGroup"/>
+                    </m:oMathParaPr>
+                    <m:oMath xmlns:m="http://schemas.openxmlformats.org/officeDocument/2006/math">
+                      <m:r>
+                        <a:rPr lang="en-SE" b="0" i="1" smtClean="0">
+                          <a:latin typeface="Cambria Math" panose="02040503050406030204" pitchFamily="18" charset="0"/>
+                        </a:rPr>
+                        <m:t>𝜇</m:t>
+                      </m:r>
+                      <m:r>
+                        <a:rPr lang="en-SE" b="0" i="1" smtClean="0">
+                          <a:latin typeface="Cambria Math" panose="02040503050406030204" pitchFamily="18" charset="0"/>
+                        </a:rPr>
+                        <m:t>=</m:t>
+                      </m:r>
+                      <m:r>
+                        <a:rPr lang="en-SE" b="0" i="1" smtClean="0">
+                          <a:latin typeface="Cambria Math" panose="02040503050406030204" pitchFamily="18" charset="0"/>
+                        </a:rPr>
+                        <m:t>𝑛𝑝</m:t>
+                      </m:r>
+                    </m:oMath>
+                  </m:oMathPara>
+                </a14:m>
+                <a:endParaRPr lang="en-SE" dirty="0"/>
+              </a:p>
+            </p:txBody>
+          </p:sp>
+        </mc:Choice>
+        <mc:Fallback>
+          <p:sp>
+            <p:nvSpPr>
+              <p:cNvPr id="45" name="TextBox 44">
+                <a:extLst>
+                  <a:ext uri="{FF2B5EF4-FFF2-40B4-BE49-F238E27FC236}">
+                    <a16:creationId xmlns:a16="http://schemas.microsoft.com/office/drawing/2014/main" id="{1C7CAFF0-31CB-C8C7-53F7-A475F6453CF6}"/>
+                  </a:ext>
+                </a:extLst>
+              </p:cNvPr>
+              <p:cNvSpPr txBox="1">
+                <a:spLocks noRot="1" noChangeAspect="1" noMove="1" noResize="1" noEditPoints="1" noAdjustHandles="1" noChangeArrowheads="1" noChangeShapeType="1" noTextEdit="1"/>
+              </p:cNvSpPr>
+              <p:nvPr/>
+            </p:nvSpPr>
+            <p:spPr>
+              <a:xfrm>
+                <a:off x="7302877" y="2076632"/>
+                <a:ext cx="744819" cy="276999"/>
+              </a:xfrm>
+              <a:prstGeom prst="rect">
+                <a:avLst/>
+              </a:prstGeom>
+              <a:blipFill>
+                <a:blip r:embed="rId13"/>
+                <a:stretch>
+                  <a:fillRect l="-8197" r="-8197" b="-26667"/>
+                </a:stretch>
+              </a:blipFill>
+            </p:spPr>
+            <p:txBody>
+              <a:bodyPr/>
+              <a:lstStyle/>
+              <a:p>
+                <a:r>
+                  <a:rPr lang="en-SE">
+                    <a:noFill/>
+                  </a:rPr>
+                  <a:t> </a:t>
+                </a:r>
+              </a:p>
+            </p:txBody>
+          </p:sp>
+        </mc:Fallback>
+      </mc:AlternateContent>
+      <mc:AlternateContent xmlns:mc="http://schemas.openxmlformats.org/markup-compatibility/2006">
+        <mc:Choice xmlns:a14="http://schemas.microsoft.com/office/drawing/2010/main" Requires="a14">
+          <p:sp>
+            <p:nvSpPr>
+              <p:cNvPr id="46" name="TextBox 45">
+                <a:extLst>
+                  <a:ext uri="{FF2B5EF4-FFF2-40B4-BE49-F238E27FC236}">
+                    <a16:creationId xmlns:a16="http://schemas.microsoft.com/office/drawing/2014/main" id="{442FE635-0A04-B3D5-B4D4-B9864793C54B}"/>
+                  </a:ext>
+                </a:extLst>
+              </p:cNvPr>
+              <p:cNvSpPr txBox="1"/>
+              <p:nvPr/>
+            </p:nvSpPr>
+            <p:spPr>
+              <a:xfrm>
+                <a:off x="6661216" y="2511165"/>
+                <a:ext cx="1594860" cy="276999"/>
+              </a:xfrm>
+              <a:prstGeom prst="rect">
+                <a:avLst/>
+              </a:prstGeom>
+              <a:noFill/>
+            </p:spPr>
+            <p:txBody>
+              <a:bodyPr wrap="none" lIns="0" tIns="0" rIns="0" bIns="0" rtlCol="0">
+                <a:spAutoFit/>
+              </a:bodyPr>
+              <a:lstStyle/>
+              <a:p>
+                <a14:m>
+                  <m:oMathPara xmlns:m="http://schemas.openxmlformats.org/officeDocument/2006/math">
+                    <m:oMathParaPr>
+                      <m:jc m:val="centerGroup"/>
+                    </m:oMathParaPr>
+                    <m:oMath xmlns:m="http://schemas.openxmlformats.org/officeDocument/2006/math">
+                      <m:sSup>
+                        <m:sSupPr>
+                          <m:ctrlPr>
+                            <a:rPr lang="en-SE" b="0" i="1" smtClean="0">
+                              <a:latin typeface="Cambria Math" panose="02040503050406030204" pitchFamily="18" charset="0"/>
+                            </a:rPr>
+                          </m:ctrlPr>
+                        </m:sSupPr>
+                        <m:e>
+                          <m:r>
+                            <a:rPr lang="en-SE" b="0" i="1" smtClean="0">
+                              <a:latin typeface="Cambria Math" panose="02040503050406030204" pitchFamily="18" charset="0"/>
+                            </a:rPr>
+                            <m:t>𝜎</m:t>
+                          </m:r>
+                        </m:e>
+                        <m:sup>
+                          <m:r>
+                            <a:rPr lang="en-SE" b="0" i="1" smtClean="0">
+                              <a:latin typeface="Cambria Math" panose="02040503050406030204" pitchFamily="18" charset="0"/>
+                            </a:rPr>
+                            <m:t>2</m:t>
+                          </m:r>
+                        </m:sup>
+                      </m:sSup>
+                      <m:r>
+                        <a:rPr lang="en-SE" b="0" i="1" smtClean="0">
+                          <a:latin typeface="Cambria Math" panose="02040503050406030204" pitchFamily="18" charset="0"/>
+                        </a:rPr>
+                        <m:t>=</m:t>
+                      </m:r>
+                      <m:r>
+                        <a:rPr lang="en-SE" b="0" i="1" smtClean="0">
+                          <a:latin typeface="Cambria Math" panose="02040503050406030204" pitchFamily="18" charset="0"/>
+                        </a:rPr>
+                        <m:t>𝑛𝑝</m:t>
+                      </m:r>
+                      <m:r>
+                        <a:rPr lang="en-SE" b="0" i="1" smtClean="0">
+                          <a:latin typeface="Cambria Math" panose="02040503050406030204" pitchFamily="18" charset="0"/>
+                        </a:rPr>
+                        <m:t>(1−</m:t>
+                      </m:r>
+                      <m:r>
+                        <a:rPr lang="en-SE" b="0" i="1" smtClean="0">
+                          <a:latin typeface="Cambria Math" panose="02040503050406030204" pitchFamily="18" charset="0"/>
+                        </a:rPr>
+                        <m:t>𝑝</m:t>
+                      </m:r>
+                      <m:r>
+                        <a:rPr lang="en-SE" b="0" i="1" smtClean="0">
+                          <a:latin typeface="Cambria Math" panose="02040503050406030204" pitchFamily="18" charset="0"/>
+                        </a:rPr>
+                        <m:t>)</m:t>
+                      </m:r>
+                    </m:oMath>
+                  </m:oMathPara>
+                </a14:m>
+                <a:endParaRPr lang="en-SE" dirty="0"/>
+              </a:p>
+            </p:txBody>
+          </p:sp>
+        </mc:Choice>
+        <mc:Fallback>
+          <p:sp>
+            <p:nvSpPr>
+              <p:cNvPr id="46" name="TextBox 45">
+                <a:extLst>
+                  <a:ext uri="{FF2B5EF4-FFF2-40B4-BE49-F238E27FC236}">
+                    <a16:creationId xmlns:a16="http://schemas.microsoft.com/office/drawing/2014/main" id="{442FE635-0A04-B3D5-B4D4-B9864793C54B}"/>
+                  </a:ext>
+                </a:extLst>
+              </p:cNvPr>
+              <p:cNvSpPr txBox="1">
+                <a:spLocks noRot="1" noChangeAspect="1" noMove="1" noResize="1" noEditPoints="1" noAdjustHandles="1" noChangeArrowheads="1" noChangeShapeType="1" noTextEdit="1"/>
+              </p:cNvSpPr>
+              <p:nvPr/>
+            </p:nvSpPr>
+            <p:spPr>
+              <a:xfrm>
+                <a:off x="6661216" y="2511165"/>
+                <a:ext cx="1594860" cy="276999"/>
+              </a:xfrm>
+              <a:prstGeom prst="rect">
+                <a:avLst/>
+              </a:prstGeom>
+              <a:blipFill>
+                <a:blip r:embed="rId14"/>
+                <a:stretch>
+                  <a:fillRect l="-1916" t="-2222" r="-5364" b="-35556"/>
+                </a:stretch>
+              </a:blipFill>
+            </p:spPr>
+            <p:txBody>
+              <a:bodyPr/>
+              <a:lstStyle/>
+              <a:p>
+                <a:r>
+                  <a:rPr lang="en-SE">
+                    <a:noFill/>
+                  </a:rPr>
+                  <a:t> </a:t>
+                </a:r>
+              </a:p>
+            </p:txBody>
+          </p:sp>
+        </mc:Fallback>
+      </mc:AlternateContent>
+      <mc:AlternateContent xmlns:mc="http://schemas.openxmlformats.org/markup-compatibility/2006">
+        <mc:Choice xmlns:a14="http://schemas.microsoft.com/office/drawing/2010/main" Requires="a14">
+          <p:sp>
+            <p:nvSpPr>
+              <p:cNvPr id="47" name="TextBox 46">
+                <a:extLst>
+                  <a:ext uri="{FF2B5EF4-FFF2-40B4-BE49-F238E27FC236}">
+                    <a16:creationId xmlns:a16="http://schemas.microsoft.com/office/drawing/2014/main" id="{1E01866B-F4FB-FACB-A520-58636EB5AEB7}"/>
+                  </a:ext>
+                </a:extLst>
+              </p:cNvPr>
+              <p:cNvSpPr txBox="1"/>
+              <p:nvPr/>
+            </p:nvSpPr>
+            <p:spPr>
+              <a:xfrm>
+                <a:off x="7458646" y="2801450"/>
+                <a:ext cx="701281" cy="276999"/>
+              </a:xfrm>
+              <a:prstGeom prst="rect">
+                <a:avLst/>
+              </a:prstGeom>
+              <a:noFill/>
+            </p:spPr>
+            <p:txBody>
+              <a:bodyPr wrap="none" lIns="0" tIns="0" rIns="0" bIns="0" rtlCol="0">
+                <a:spAutoFit/>
+              </a:bodyPr>
+              <a:lstStyle/>
+              <a:p>
+                <a14:m>
+                  <m:oMathPara xmlns:m="http://schemas.openxmlformats.org/officeDocument/2006/math">
+                    <m:oMathParaPr>
+                      <m:jc m:val="centerGroup"/>
+                    </m:oMathParaPr>
+                    <m:oMath xmlns:m="http://schemas.openxmlformats.org/officeDocument/2006/math">
+                      <m:r>
+                        <a:rPr lang="en-SE" b="0" i="1" smtClean="0">
+                          <a:latin typeface="Cambria Math" panose="02040503050406030204" pitchFamily="18" charset="0"/>
+                        </a:rPr>
+                        <m:t>𝑛</m:t>
+                      </m:r>
+                      <m:r>
+                        <a:rPr lang="en-SE" b="0" i="1" smtClean="0">
+                          <a:latin typeface="Cambria Math" panose="02040503050406030204" pitchFamily="18" charset="0"/>
+                        </a:rPr>
+                        <m:t>→∞</m:t>
+                      </m:r>
+                    </m:oMath>
+                  </m:oMathPara>
+                </a14:m>
+                <a:endParaRPr lang="en-SE" dirty="0"/>
+              </a:p>
+            </p:txBody>
+          </p:sp>
+        </mc:Choice>
+        <mc:Fallback>
+          <p:sp>
+            <p:nvSpPr>
+              <p:cNvPr id="47" name="TextBox 46">
+                <a:extLst>
+                  <a:ext uri="{FF2B5EF4-FFF2-40B4-BE49-F238E27FC236}">
+                    <a16:creationId xmlns:a16="http://schemas.microsoft.com/office/drawing/2014/main" id="{1E01866B-F4FB-FACB-A520-58636EB5AEB7}"/>
+                  </a:ext>
+                </a:extLst>
+              </p:cNvPr>
+              <p:cNvSpPr txBox="1">
+                <a:spLocks noRot="1" noChangeAspect="1" noMove="1" noResize="1" noEditPoints="1" noAdjustHandles="1" noChangeArrowheads="1" noChangeShapeType="1" noTextEdit="1"/>
+              </p:cNvSpPr>
+              <p:nvPr/>
+            </p:nvSpPr>
+            <p:spPr>
+              <a:xfrm>
+                <a:off x="7458646" y="2801450"/>
+                <a:ext cx="701281" cy="276999"/>
+              </a:xfrm>
+              <a:prstGeom prst="rect">
+                <a:avLst/>
+              </a:prstGeom>
+              <a:blipFill>
+                <a:blip r:embed="rId15"/>
+                <a:stretch>
+                  <a:fillRect l="-5217" r="-4348"/>
+                </a:stretch>
+              </a:blipFill>
+            </p:spPr>
+            <p:txBody>
+              <a:bodyPr/>
+              <a:lstStyle/>
+              <a:p>
+                <a:r>
+                  <a:rPr lang="en-SE">
+                    <a:noFill/>
+                  </a:rPr>
+                  <a:t> </a:t>
+                </a:r>
+              </a:p>
+            </p:txBody>
+          </p:sp>
+        </mc:Fallback>
+      </mc:AlternateContent>
+      <p:cxnSp>
+        <p:nvCxnSpPr>
+          <p:cNvPr id="48" name="Connector: Curved 18">
+            <a:extLst>
+              <a:ext uri="{FF2B5EF4-FFF2-40B4-BE49-F238E27FC236}">
+                <a16:creationId xmlns:a16="http://schemas.microsoft.com/office/drawing/2014/main" id="{3E423C2F-DCCC-3580-B892-B2230DEE45D5}"/>
+              </a:ext>
+            </a:extLst>
+          </p:cNvPr>
+          <p:cNvCxnSpPr>
+            <a:cxnSpLocks/>
+          </p:cNvCxnSpPr>
+          <p:nvPr/>
+        </p:nvCxnSpPr>
+        <p:spPr>
+          <a:xfrm flipH="1">
+            <a:off x="4247209" y="1738264"/>
+            <a:ext cx="4008867" cy="0"/>
+          </a:xfrm>
+          <a:prstGeom prst="straightConnector1">
+            <a:avLst/>
+          </a:prstGeom>
+          <a:ln>
+            <a:tailEnd type="triangle"/>
+          </a:ln>
+        </p:spPr>
+        <p:style>
+          <a:lnRef idx="2">
+            <a:schemeClr val="accent1"/>
+          </a:lnRef>
+          <a:fillRef idx="0">
+            <a:schemeClr val="accent1"/>
+          </a:fillRef>
+          <a:effectRef idx="1">
+            <a:schemeClr val="accent1"/>
+          </a:effectRef>
+          <a:fontRef idx="minor">
+            <a:schemeClr val="tx1"/>
+          </a:fontRef>
+        </p:style>
+      </p:cxnSp>
+      <mc:AlternateContent xmlns:mc="http://schemas.openxmlformats.org/markup-compatibility/2006">
+        <mc:Choice xmlns:a14="http://schemas.microsoft.com/office/drawing/2010/main" Requires="a14">
+          <p:sp>
+            <p:nvSpPr>
+              <p:cNvPr id="52" name="TextBox 51">
+                <a:extLst>
+                  <a:ext uri="{FF2B5EF4-FFF2-40B4-BE49-F238E27FC236}">
+                    <a16:creationId xmlns:a16="http://schemas.microsoft.com/office/drawing/2014/main" id="{EBB1798F-5D8E-52A4-52C0-070DEC314757}"/>
+                  </a:ext>
+                </a:extLst>
+              </p:cNvPr>
+              <p:cNvSpPr txBox="1"/>
+              <p:nvPr/>
+            </p:nvSpPr>
+            <p:spPr>
+              <a:xfrm>
+                <a:off x="5241061" y="1418808"/>
+                <a:ext cx="744819" cy="276999"/>
+              </a:xfrm>
+              <a:prstGeom prst="rect">
+                <a:avLst/>
+              </a:prstGeom>
+              <a:noFill/>
+            </p:spPr>
+            <p:txBody>
+              <a:bodyPr wrap="none" lIns="0" tIns="0" rIns="0" bIns="0" rtlCol="0">
+                <a:spAutoFit/>
+              </a:bodyPr>
+              <a:lstStyle/>
+              <a:p>
+                <a14:m>
+                  <m:oMathPara xmlns:m="http://schemas.openxmlformats.org/officeDocument/2006/math">
+                    <m:oMathParaPr>
+                      <m:jc m:val="centerGroup"/>
+                    </m:oMathParaPr>
+                    <m:oMath xmlns:m="http://schemas.openxmlformats.org/officeDocument/2006/math">
+                      <m:r>
+                        <a:rPr lang="en-SE" b="0" i="1" smtClean="0">
+                          <a:latin typeface="Cambria Math" panose="02040503050406030204" pitchFamily="18" charset="0"/>
+                        </a:rPr>
+                        <m:t>𝜇</m:t>
+                      </m:r>
+                      <m:r>
+                        <a:rPr lang="en-SE" b="0" i="1" smtClean="0">
+                          <a:latin typeface="Cambria Math" panose="02040503050406030204" pitchFamily="18" charset="0"/>
+                        </a:rPr>
+                        <m:t>=</m:t>
+                      </m:r>
+                      <m:r>
+                        <a:rPr lang="en-SE" b="0" i="1" smtClean="0">
+                          <a:latin typeface="Cambria Math" panose="02040503050406030204" pitchFamily="18" charset="0"/>
+                        </a:rPr>
+                        <m:t>𝑛𝑝</m:t>
+                      </m:r>
+                    </m:oMath>
+                  </m:oMathPara>
+                </a14:m>
+                <a:endParaRPr lang="en-SE" dirty="0"/>
+              </a:p>
+            </p:txBody>
+          </p:sp>
+        </mc:Choice>
+        <mc:Fallback>
+          <p:sp>
+            <p:nvSpPr>
+              <p:cNvPr id="52" name="TextBox 51">
+                <a:extLst>
+                  <a:ext uri="{FF2B5EF4-FFF2-40B4-BE49-F238E27FC236}">
+                    <a16:creationId xmlns:a16="http://schemas.microsoft.com/office/drawing/2014/main" id="{EBB1798F-5D8E-52A4-52C0-070DEC314757}"/>
+                  </a:ext>
+                </a:extLst>
+              </p:cNvPr>
+              <p:cNvSpPr txBox="1">
+                <a:spLocks noRot="1" noChangeAspect="1" noMove="1" noResize="1" noEditPoints="1" noAdjustHandles="1" noChangeArrowheads="1" noChangeShapeType="1" noTextEdit="1"/>
+              </p:cNvSpPr>
+              <p:nvPr/>
+            </p:nvSpPr>
+            <p:spPr>
+              <a:xfrm>
+                <a:off x="5241061" y="1418808"/>
+                <a:ext cx="744819" cy="276999"/>
+              </a:xfrm>
+              <a:prstGeom prst="rect">
+                <a:avLst/>
+              </a:prstGeom>
+              <a:blipFill>
+                <a:blip r:embed="rId16"/>
+                <a:stretch>
+                  <a:fillRect l="-8197" r="-8197" b="-26667"/>
+                </a:stretch>
+              </a:blipFill>
+            </p:spPr>
+            <p:txBody>
+              <a:bodyPr/>
+              <a:lstStyle/>
+              <a:p>
+                <a:r>
+                  <a:rPr lang="en-SE">
+                    <a:noFill/>
+                  </a:rPr>
+                  <a:t> </a:t>
+                </a:r>
+              </a:p>
+            </p:txBody>
+          </p:sp>
+        </mc:Fallback>
+      </mc:AlternateContent>
+      <mc:AlternateContent xmlns:mc="http://schemas.openxmlformats.org/markup-compatibility/2006">
+        <mc:Choice xmlns:a14="http://schemas.microsoft.com/office/drawing/2010/main" Requires="a14">
+          <p:sp>
+            <p:nvSpPr>
+              <p:cNvPr id="53" name="TextBox 52">
+                <a:extLst>
+                  <a:ext uri="{FF2B5EF4-FFF2-40B4-BE49-F238E27FC236}">
+                    <a16:creationId xmlns:a16="http://schemas.microsoft.com/office/drawing/2014/main" id="{EA5611E2-5691-F3C4-9B99-0AA7397773C4}"/>
+                  </a:ext>
+                </a:extLst>
+              </p:cNvPr>
+              <p:cNvSpPr txBox="1"/>
+              <p:nvPr/>
+            </p:nvSpPr>
+            <p:spPr>
+              <a:xfrm>
+                <a:off x="6091584" y="1422434"/>
+                <a:ext cx="701281" cy="276999"/>
+              </a:xfrm>
+              <a:prstGeom prst="rect">
+                <a:avLst/>
+              </a:prstGeom>
+              <a:noFill/>
+            </p:spPr>
+            <p:txBody>
+              <a:bodyPr wrap="none" lIns="0" tIns="0" rIns="0" bIns="0" rtlCol="0">
+                <a:spAutoFit/>
+              </a:bodyPr>
+              <a:lstStyle/>
+              <a:p>
+                <a14:m>
+                  <m:oMathPara xmlns:m="http://schemas.openxmlformats.org/officeDocument/2006/math">
+                    <m:oMathParaPr>
+                      <m:jc m:val="centerGroup"/>
+                    </m:oMathParaPr>
+                    <m:oMath xmlns:m="http://schemas.openxmlformats.org/officeDocument/2006/math">
+                      <m:r>
+                        <a:rPr lang="en-SE" b="0" i="1" smtClean="0">
+                          <a:latin typeface="Cambria Math" panose="02040503050406030204" pitchFamily="18" charset="0"/>
+                        </a:rPr>
+                        <m:t>𝑛</m:t>
+                      </m:r>
+                      <m:r>
+                        <a:rPr lang="en-SE" b="0" i="1" smtClean="0">
+                          <a:latin typeface="Cambria Math" panose="02040503050406030204" pitchFamily="18" charset="0"/>
+                        </a:rPr>
+                        <m:t>→∞</m:t>
+                      </m:r>
+                    </m:oMath>
+                  </m:oMathPara>
+                </a14:m>
+                <a:endParaRPr lang="en-SE" dirty="0"/>
+              </a:p>
+            </p:txBody>
+          </p:sp>
+        </mc:Choice>
+        <mc:Fallback>
+          <p:sp>
+            <p:nvSpPr>
+              <p:cNvPr id="53" name="TextBox 52">
+                <a:extLst>
+                  <a:ext uri="{FF2B5EF4-FFF2-40B4-BE49-F238E27FC236}">
+                    <a16:creationId xmlns:a16="http://schemas.microsoft.com/office/drawing/2014/main" id="{EA5611E2-5691-F3C4-9B99-0AA7397773C4}"/>
+                  </a:ext>
+                </a:extLst>
+              </p:cNvPr>
+              <p:cNvSpPr txBox="1">
+                <a:spLocks noRot="1" noChangeAspect="1" noMove="1" noResize="1" noEditPoints="1" noAdjustHandles="1" noChangeArrowheads="1" noChangeShapeType="1" noTextEdit="1"/>
+              </p:cNvSpPr>
+              <p:nvPr/>
+            </p:nvSpPr>
+            <p:spPr>
+              <a:xfrm>
+                <a:off x="6091584" y="1422434"/>
+                <a:ext cx="701281" cy="276999"/>
+              </a:xfrm>
+              <a:prstGeom prst="rect">
+                <a:avLst/>
+              </a:prstGeom>
+              <a:blipFill>
+                <a:blip r:embed="rId17"/>
+                <a:stretch>
+                  <a:fillRect l="-5217" r="-5217"/>
+                </a:stretch>
+              </a:blipFill>
+            </p:spPr>
+            <p:txBody>
+              <a:bodyPr/>
+              <a:lstStyle/>
+              <a:p>
+                <a:r>
+                  <a:rPr lang="en-SE">
+                    <a:noFill/>
+                  </a:rPr>
+                  <a:t> </a:t>
+                </a:r>
+              </a:p>
+            </p:txBody>
+          </p:sp>
+        </mc:Fallback>
+      </mc:AlternateContent>
     </p:spTree>
     <p:extLst>
       <p:ext uri="{BB962C8B-B14F-4D97-AF65-F5344CB8AC3E}">
-        <p14:creationId xmlns:p14="http://schemas.microsoft.com/office/powerpoint/2010/main" val="3897272715"/>
+        <p14:creationId xmlns:p14="http://schemas.microsoft.com/office/powerpoint/2010/main" val="3880003461"/>
       </p:ext>
     </p:extLst>
   </p:cSld>
   <p:clrMapOvr>
     <a:masterClrMapping/>
   </p:clrMapOvr>
-  <p:timing>
-    <p:tnLst>
-      <p:par>
-        <p:cTn id="1" dur="indefinite" restart="never" nodeType="tmRoot">
-          <p:childTnLst>
-            <p:seq concurrent="1" nextAc="seek">
-              <p:cTn id="2" dur="indefinite" nodeType="mainSeq">
-                <p:childTnLst>
-                  <p:par>
-                    <p:cTn id="3" fill="hold">
-                      <p:stCondLst>
-                        <p:cond delay="indefinite"/>
-                      </p:stCondLst>
-                      <p:childTnLst>
-                        <p:par>
-                          <p:cTn id="4" fill="hold">
-                            <p:stCondLst>
-                              <p:cond delay="0"/>
-                            </p:stCondLst>
-                            <p:childTnLst>
-                              <p:par>
-                                <p:cTn id="5" presetID="1" presetClass="entr" presetSubtype="0" fill="hold" grpId="0" nodeType="clickEffect">
-                                  <p:stCondLst>
-                                    <p:cond delay="0"/>
-                                  </p:stCondLst>
-                                  <p:childTnLst>
-                                    <p:set>
-                                      <p:cBhvr>
-                                        <p:cTn id="6" dur="1" fill="hold">
-                                          <p:stCondLst>
-                                            <p:cond delay="0"/>
-                                          </p:stCondLst>
-                                        </p:cTn>
-                                        <p:tgtEl>
-                                          <p:spTgt spid="7"/>
-                                        </p:tgtEl>
-                                        <p:attrNameLst>
-                                          <p:attrName>style.visibility</p:attrName>
-                                        </p:attrNameLst>
-                                      </p:cBhvr>
-                                      <p:to>
-                                        <p:strVal val="visible"/>
-                                      </p:to>
-                                    </p:set>
-                                  </p:childTnLst>
-                                </p:cTn>
-                              </p:par>
-                            </p:childTnLst>
-                          </p:cTn>
-                        </p:par>
-                      </p:childTnLst>
-                    </p:cTn>
-                  </p:par>
-                  <p:par>
-                    <p:cTn id="7" fill="hold">
-                      <p:stCondLst>
-                        <p:cond delay="indefinite"/>
-                      </p:stCondLst>
-                      <p:childTnLst>
-                        <p:par>
-                          <p:cTn id="8" fill="hold">
-                            <p:stCondLst>
-                              <p:cond delay="0"/>
-                            </p:stCondLst>
-                            <p:childTnLst>
-                              <p:par>
-                                <p:cTn id="9" presetID="1" presetClass="entr" presetSubtype="0" fill="hold" nodeType="clickEffect">
-                                  <p:stCondLst>
-                                    <p:cond delay="0"/>
-                                  </p:stCondLst>
-                                  <p:childTnLst>
-                                    <p:set>
-                                      <p:cBhvr>
-                                        <p:cTn id="10" dur="1" fill="hold">
-                                          <p:stCondLst>
-                                            <p:cond delay="0"/>
-                                          </p:stCondLst>
-                                        </p:cTn>
-                                        <p:tgtEl>
-                                          <p:spTgt spid="15"/>
-                                        </p:tgtEl>
-                                        <p:attrNameLst>
-                                          <p:attrName>style.visibility</p:attrName>
-                                        </p:attrNameLst>
-                                      </p:cBhvr>
-                                      <p:to>
-                                        <p:strVal val="visible"/>
-                                      </p:to>
-                                    </p:set>
-                                  </p:childTnLst>
-                                </p:cTn>
-                              </p:par>
-                            </p:childTnLst>
-                          </p:cTn>
-                        </p:par>
-                      </p:childTnLst>
-                    </p:cTn>
-                  </p:par>
-                </p:childTnLst>
-              </p:cTn>
-              <p:prevCondLst>
-                <p:cond evt="onPrev" delay="0">
-                  <p:tgtEl>
-                    <p:sldTgt/>
-                  </p:tgtEl>
-                </p:cond>
-              </p:prevCondLst>
-              <p:nextCondLst>
-                <p:cond evt="onNext" delay="0">
-                  <p:tgtEl>
-                    <p:sldTgt/>
-                  </p:tgtEl>
-                </p:cond>
-              </p:nextCondLst>
-            </p:seq>
-          </p:childTnLst>
-        </p:cTn>
-      </p:par>
-    </p:tnLst>
-    <p:bldLst>
-      <p:bldP spid="7" grpId="0" animBg="1"/>
-    </p:bldLst>
-  </p:timing>
 </p:sld>
 </file>
 
@@ -29970,6 +31395,668 @@
           <p:cNvPr id="2" name="Title 1">
             <a:extLst>
               <a:ext uri="{FF2B5EF4-FFF2-40B4-BE49-F238E27FC236}">
+                <a16:creationId xmlns:a16="http://schemas.microsoft.com/office/drawing/2014/main" id="{31E94E9E-B26D-41EE-C664-11CD9A0944D1}"/>
+              </a:ext>
+            </a:extLst>
+          </p:cNvPr>
+          <p:cNvSpPr>
+            <a:spLocks noGrp="1"/>
+          </p:cNvSpPr>
+          <p:nvPr>
+            <p:ph type="title"/>
+          </p:nvPr>
+        </p:nvSpPr>
+        <p:spPr/>
+        <p:txBody>
+          <a:bodyPr/>
+          <a:lstStyle/>
+          <a:p>
+            <a:r>
+              <a:rPr lang="en-SE" dirty="0"/>
+              <a:t>Constructing a Bayesian Model</a:t>
+            </a:r>
+          </a:p>
+        </p:txBody>
+      </p:sp>
+      <p:sp>
+        <p:nvSpPr>
+          <p:cNvPr id="3" name="Content Placeholder 2">
+            <a:extLst>
+              <a:ext uri="{FF2B5EF4-FFF2-40B4-BE49-F238E27FC236}">
+                <a16:creationId xmlns:a16="http://schemas.microsoft.com/office/drawing/2014/main" id="{FADA05B7-5E9A-2B29-605F-5A878B4DF333}"/>
+              </a:ext>
+            </a:extLst>
+          </p:cNvPr>
+          <p:cNvSpPr>
+            <a:spLocks noGrp="1"/>
+          </p:cNvSpPr>
+          <p:nvPr>
+            <p:ph idx="1"/>
+          </p:nvPr>
+        </p:nvSpPr>
+        <p:spPr>
+          <a:xfrm>
+            <a:off x="838200" y="1825625"/>
+            <a:ext cx="10515600" cy="1100455"/>
+          </a:xfrm>
+        </p:spPr>
+        <p:txBody>
+          <a:bodyPr/>
+          <a:lstStyle/>
+          <a:p>
+            <a:pPr marL="0" indent="0">
+              <a:buNone/>
+            </a:pPr>
+            <a:r>
+              <a:rPr lang="en-SE" dirty="0"/>
+              <a:t>Since some parameters of some distribution families underly certain constraints, a Bayesian model may involve </a:t>
+            </a:r>
+            <a:r>
+              <a:rPr lang="en-SE" b="1" dirty="0"/>
+              <a:t>link functions.</a:t>
+            </a:r>
+            <a:endParaRPr lang="en-SE" dirty="0"/>
+          </a:p>
+        </p:txBody>
+      </p:sp>
+      <p:sp>
+        <p:nvSpPr>
+          <p:cNvPr id="4" name="Date Placeholder 3">
+            <a:extLst>
+              <a:ext uri="{FF2B5EF4-FFF2-40B4-BE49-F238E27FC236}">
+                <a16:creationId xmlns:a16="http://schemas.microsoft.com/office/drawing/2014/main" id="{D2845B5B-9D0F-E6A7-5927-2CCC5DD3E858}"/>
+              </a:ext>
+            </a:extLst>
+          </p:cNvPr>
+          <p:cNvSpPr>
+            <a:spLocks noGrp="1"/>
+          </p:cNvSpPr>
+          <p:nvPr>
+            <p:ph type="dt" sz="half" idx="10"/>
+          </p:nvPr>
+        </p:nvSpPr>
+        <p:spPr/>
+        <p:txBody>
+          <a:bodyPr/>
+          <a:lstStyle/>
+          <a:p>
+            <a:r>
+              <a:rPr lang="en-US"/>
+              <a:t>2024-10-17</a:t>
+            </a:r>
+          </a:p>
+        </p:txBody>
+      </p:sp>
+      <p:sp>
+        <p:nvSpPr>
+          <p:cNvPr id="5" name="Footer Placeholder 4">
+            <a:extLst>
+              <a:ext uri="{FF2B5EF4-FFF2-40B4-BE49-F238E27FC236}">
+                <a16:creationId xmlns:a16="http://schemas.microsoft.com/office/drawing/2014/main" id="{4FCD6AED-1BF9-E8F5-353A-894344E56134}"/>
+              </a:ext>
+            </a:extLst>
+          </p:cNvPr>
+          <p:cNvSpPr>
+            <a:spLocks noGrp="1"/>
+          </p:cNvSpPr>
+          <p:nvPr>
+            <p:ph type="ftr" sz="quarter" idx="11"/>
+          </p:nvPr>
+        </p:nvSpPr>
+        <p:spPr/>
+        <p:txBody>
+          <a:bodyPr/>
+          <a:lstStyle/>
+          <a:p>
+            <a:r>
+              <a:rPr lang="en-US"/>
+              <a:t>Bayesian Data Analysis for Statistical Causal Inference</a:t>
+            </a:r>
+          </a:p>
+        </p:txBody>
+      </p:sp>
+      <p:sp>
+        <p:nvSpPr>
+          <p:cNvPr id="6" name="Slide Number Placeholder 5">
+            <a:extLst>
+              <a:ext uri="{FF2B5EF4-FFF2-40B4-BE49-F238E27FC236}">
+                <a16:creationId xmlns:a16="http://schemas.microsoft.com/office/drawing/2014/main" id="{5F05D22B-23EA-ABF0-BFFE-ECA1C999FA69}"/>
+              </a:ext>
+            </a:extLst>
+          </p:cNvPr>
+          <p:cNvSpPr>
+            <a:spLocks noGrp="1"/>
+          </p:cNvSpPr>
+          <p:nvPr>
+            <p:ph type="sldNum" sz="quarter" idx="12"/>
+          </p:nvPr>
+        </p:nvSpPr>
+        <p:spPr/>
+        <p:txBody>
+          <a:bodyPr/>
+          <a:lstStyle/>
+          <a:p>
+            <a:fld id="{C6EBE6D1-86F0-4C3A-8077-EBA4C5B4BE81}" type="slidenum">
+              <a:rPr lang="en-US" smtClean="0"/>
+              <a:t>50</a:t>
+            </a:fld>
+            <a:endParaRPr lang="en-US"/>
+          </a:p>
+        </p:txBody>
+      </p:sp>
+      <p:pic>
+        <p:nvPicPr>
+          <p:cNvPr id="8" name="Picture 7">
+            <a:extLst>
+              <a:ext uri="{FF2B5EF4-FFF2-40B4-BE49-F238E27FC236}">
+                <a16:creationId xmlns:a16="http://schemas.microsoft.com/office/drawing/2014/main" id="{C1053DC1-3A15-C497-3BC7-050943EFCE50}"/>
+              </a:ext>
+            </a:extLst>
+          </p:cNvPr>
+          <p:cNvPicPr>
+            <a:picLocks noChangeAspect="1"/>
+          </p:cNvPicPr>
+          <p:nvPr/>
+        </p:nvPicPr>
+        <p:blipFill>
+          <a:blip r:embed="rId2"/>
+          <a:stretch>
+            <a:fillRect/>
+          </a:stretch>
+        </p:blipFill>
+        <p:spPr>
+          <a:xfrm>
+            <a:off x="2354381" y="2926080"/>
+            <a:ext cx="7483238" cy="3239014"/>
+          </a:xfrm>
+          <a:prstGeom prst="rect">
+            <a:avLst/>
+          </a:prstGeom>
+        </p:spPr>
+      </p:pic>
+    </p:spTree>
+    <p:extLst>
+      <p:ext uri="{BB962C8B-B14F-4D97-AF65-F5344CB8AC3E}">
+        <p14:creationId xmlns:p14="http://schemas.microsoft.com/office/powerpoint/2010/main" val="4171206609"/>
+      </p:ext>
+    </p:extLst>
+  </p:cSld>
+  <p:clrMapOvr>
+    <a:masterClrMapping/>
+  </p:clrMapOvr>
+</p:sld>
+</file>
+
+<file path=ppt/slides/slide51.xml><?xml version="1.0" encoding="utf-8"?>
+<p:sld xmlns:a="http://schemas.openxmlformats.org/drawingml/2006/main" xmlns:r="http://schemas.openxmlformats.org/officeDocument/2006/relationships" xmlns:p="http://schemas.openxmlformats.org/presentationml/2006/main">
+  <p:cSld>
+    <p:spTree>
+      <p:nvGrpSpPr>
+        <p:cNvPr id="1" name=""/>
+        <p:cNvGrpSpPr/>
+        <p:nvPr/>
+      </p:nvGrpSpPr>
+      <p:grpSpPr>
+        <a:xfrm>
+          <a:off x="0" y="0"/>
+          <a:ext cx="0" cy="0"/>
+          <a:chOff x="0" y="0"/>
+          <a:chExt cx="0" cy="0"/>
+        </a:xfrm>
+      </p:grpSpPr>
+      <p:sp>
+        <p:nvSpPr>
+          <p:cNvPr id="2" name="Title 1">
+            <a:extLst>
+              <a:ext uri="{FF2B5EF4-FFF2-40B4-BE49-F238E27FC236}">
+                <a16:creationId xmlns:a16="http://schemas.microsoft.com/office/drawing/2014/main" id="{3CC60B4B-88BC-CFD5-84E5-9BE4E0E29223}"/>
+              </a:ext>
+            </a:extLst>
+          </p:cNvPr>
+          <p:cNvSpPr>
+            <a:spLocks noGrp="1"/>
+          </p:cNvSpPr>
+          <p:nvPr>
+            <p:ph type="title"/>
+          </p:nvPr>
+        </p:nvSpPr>
+        <p:spPr/>
+        <p:txBody>
+          <a:bodyPr/>
+          <a:lstStyle/>
+          <a:p>
+            <a:r>
+              <a:rPr lang="en-US" dirty="0"/>
+              <a:t>Demonstration of the Bayesian Approach</a:t>
+            </a:r>
+          </a:p>
+        </p:txBody>
+      </p:sp>
+      <p:sp>
+        <p:nvSpPr>
+          <p:cNvPr id="3" name="Content Placeholder 2">
+            <a:extLst>
+              <a:ext uri="{FF2B5EF4-FFF2-40B4-BE49-F238E27FC236}">
+                <a16:creationId xmlns:a16="http://schemas.microsoft.com/office/drawing/2014/main" id="{AE6DDF7A-9D5F-F440-7B32-642DD080540C}"/>
+              </a:ext>
+            </a:extLst>
+          </p:cNvPr>
+          <p:cNvSpPr>
+            <a:spLocks noGrp="1"/>
+          </p:cNvSpPr>
+          <p:nvPr>
+            <p:ph idx="1"/>
+          </p:nvPr>
+        </p:nvSpPr>
+        <p:spPr>
+          <a:xfrm>
+            <a:off x="838200" y="1825625"/>
+            <a:ext cx="10515600" cy="1112647"/>
+          </a:xfrm>
+        </p:spPr>
+        <p:txBody>
+          <a:bodyPr/>
+          <a:lstStyle/>
+          <a:p>
+            <a:pPr marL="514350" indent="-514350">
+              <a:buFont typeface="+mj-lt"/>
+              <a:buAutoNum type="arabicPeriod" startAt="2"/>
+            </a:pPr>
+            <a:r>
+              <a:rPr lang="en-US" dirty="0"/>
+              <a:t>Determine </a:t>
+            </a:r>
+            <a:r>
+              <a:rPr lang="en-US" b="1" dirty="0"/>
+              <a:t>model distribution</a:t>
+            </a:r>
+          </a:p>
+          <a:p>
+            <a:pPr marL="514350" indent="-514350">
+              <a:buFont typeface="+mj-lt"/>
+              <a:buAutoNum type="arabicPeriod" startAt="2"/>
+            </a:pPr>
+            <a:r>
+              <a:rPr lang="en-US" dirty="0"/>
+              <a:t>Select </a:t>
+            </a:r>
+            <a:r>
+              <a:rPr lang="en-US" b="1" dirty="0"/>
+              <a:t>priors</a:t>
+            </a:r>
+            <a:r>
+              <a:rPr lang="en-US" dirty="0"/>
+              <a:t> for all included factors</a:t>
+            </a:r>
+            <a:endParaRPr lang="en-US" b="1" dirty="0"/>
+          </a:p>
+          <a:p>
+            <a:pPr marL="0" indent="0">
+              <a:buNone/>
+            </a:pPr>
+            <a:endParaRPr lang="en-US" b="1" dirty="0"/>
+          </a:p>
+        </p:txBody>
+      </p:sp>
+      <p:sp>
+        <p:nvSpPr>
+          <p:cNvPr id="4" name="Date Placeholder 3">
+            <a:extLst>
+              <a:ext uri="{FF2B5EF4-FFF2-40B4-BE49-F238E27FC236}">
+                <a16:creationId xmlns:a16="http://schemas.microsoft.com/office/drawing/2014/main" id="{79DFEEAF-0645-40DC-1613-53DC1272DA26}"/>
+              </a:ext>
+            </a:extLst>
+          </p:cNvPr>
+          <p:cNvSpPr>
+            <a:spLocks noGrp="1"/>
+          </p:cNvSpPr>
+          <p:nvPr>
+            <p:ph type="dt" sz="half" idx="10"/>
+          </p:nvPr>
+        </p:nvSpPr>
+        <p:spPr/>
+        <p:txBody>
+          <a:bodyPr/>
+          <a:lstStyle/>
+          <a:p>
+            <a:r>
+              <a:rPr lang="en-US"/>
+              <a:t>2024-10-17</a:t>
+            </a:r>
+          </a:p>
+        </p:txBody>
+      </p:sp>
+      <p:sp>
+        <p:nvSpPr>
+          <p:cNvPr id="5" name="Footer Placeholder 4">
+            <a:extLst>
+              <a:ext uri="{FF2B5EF4-FFF2-40B4-BE49-F238E27FC236}">
+                <a16:creationId xmlns:a16="http://schemas.microsoft.com/office/drawing/2014/main" id="{C98C849D-2278-2A3E-2143-3AE40709C946}"/>
+              </a:ext>
+            </a:extLst>
+          </p:cNvPr>
+          <p:cNvSpPr>
+            <a:spLocks noGrp="1"/>
+          </p:cNvSpPr>
+          <p:nvPr>
+            <p:ph type="ftr" sz="quarter" idx="11"/>
+          </p:nvPr>
+        </p:nvSpPr>
+        <p:spPr/>
+        <p:txBody>
+          <a:bodyPr/>
+          <a:lstStyle/>
+          <a:p>
+            <a:r>
+              <a:rPr lang="en-US"/>
+              <a:t>Bayesian Data Analysis for Statistical Causal Inference</a:t>
+            </a:r>
+          </a:p>
+        </p:txBody>
+      </p:sp>
+      <p:sp>
+        <p:nvSpPr>
+          <p:cNvPr id="6" name="Slide Number Placeholder 5">
+            <a:extLst>
+              <a:ext uri="{FF2B5EF4-FFF2-40B4-BE49-F238E27FC236}">
+                <a16:creationId xmlns:a16="http://schemas.microsoft.com/office/drawing/2014/main" id="{FE3FC949-DD4C-284A-2B86-13FADF39C339}"/>
+              </a:ext>
+            </a:extLst>
+          </p:cNvPr>
+          <p:cNvSpPr>
+            <a:spLocks noGrp="1"/>
+          </p:cNvSpPr>
+          <p:nvPr>
+            <p:ph type="sldNum" sz="quarter" idx="12"/>
+          </p:nvPr>
+        </p:nvSpPr>
+        <p:spPr/>
+        <p:txBody>
+          <a:bodyPr/>
+          <a:lstStyle/>
+          <a:p>
+            <a:fld id="{C6EBE6D1-86F0-4C3A-8077-EBA4C5B4BE81}" type="slidenum">
+              <a:rPr lang="en-US" smtClean="0"/>
+              <a:t>51</a:t>
+            </a:fld>
+            <a:endParaRPr lang="en-US"/>
+          </a:p>
+        </p:txBody>
+      </p:sp>
+      <p:pic>
+        <p:nvPicPr>
+          <p:cNvPr id="13" name="Picture 12">
+            <a:extLst>
+              <a:ext uri="{FF2B5EF4-FFF2-40B4-BE49-F238E27FC236}">
+                <a16:creationId xmlns:a16="http://schemas.microsoft.com/office/drawing/2014/main" id="{4DCD1F97-35CA-8612-A0BF-51F62C52C82E}"/>
+              </a:ext>
+            </a:extLst>
+          </p:cNvPr>
+          <p:cNvPicPr>
+            <a:picLocks noChangeAspect="1"/>
+          </p:cNvPicPr>
+          <p:nvPr/>
+        </p:nvPicPr>
+        <p:blipFill>
+          <a:blip r:embed="rId2"/>
+          <a:stretch>
+            <a:fillRect/>
+          </a:stretch>
+        </p:blipFill>
+        <p:spPr>
+          <a:xfrm>
+            <a:off x="838200" y="3326511"/>
+            <a:ext cx="6743700" cy="2228850"/>
+          </a:xfrm>
+          <a:prstGeom prst="rect">
+            <a:avLst/>
+          </a:prstGeom>
+        </p:spPr>
+      </p:pic>
+      <p:pic>
+        <p:nvPicPr>
+          <p:cNvPr id="15" name="Picture 14">
+            <a:extLst>
+              <a:ext uri="{FF2B5EF4-FFF2-40B4-BE49-F238E27FC236}">
+                <a16:creationId xmlns:a16="http://schemas.microsoft.com/office/drawing/2014/main" id="{0DD349AB-B2EE-FCE0-ACFC-38D85A46EEC2}"/>
+              </a:ext>
+            </a:extLst>
+          </p:cNvPr>
+          <p:cNvPicPr>
+            <a:picLocks noChangeAspect="1"/>
+          </p:cNvPicPr>
+          <p:nvPr/>
+        </p:nvPicPr>
+        <p:blipFill>
+          <a:blip r:embed="rId3"/>
+          <a:stretch>
+            <a:fillRect/>
+          </a:stretch>
+        </p:blipFill>
+        <p:spPr>
+          <a:xfrm>
+            <a:off x="7820977" y="3429000"/>
+            <a:ext cx="3743325" cy="914400"/>
+          </a:xfrm>
+          <a:prstGeom prst="rect">
+            <a:avLst/>
+          </a:prstGeom>
+        </p:spPr>
+      </p:pic>
+      <p:sp>
+        <p:nvSpPr>
+          <p:cNvPr id="7" name="Rectangle 6">
+            <a:extLst>
+              <a:ext uri="{FF2B5EF4-FFF2-40B4-BE49-F238E27FC236}">
+                <a16:creationId xmlns:a16="http://schemas.microsoft.com/office/drawing/2014/main" id="{19EFAC25-EBDD-D08F-73C8-ECED879F2850}"/>
+              </a:ext>
+            </a:extLst>
+          </p:cNvPr>
+          <p:cNvSpPr/>
+          <p:nvPr/>
+        </p:nvSpPr>
+        <p:spPr>
+          <a:xfrm>
+            <a:off x="1354824" y="3886200"/>
+            <a:ext cx="1374090" cy="200025"/>
+          </a:xfrm>
+          <a:prstGeom prst="rect">
+            <a:avLst/>
+          </a:prstGeom>
+          <a:solidFill>
+            <a:schemeClr val="accent1">
+              <a:lumMod val="40000"/>
+              <a:lumOff val="60000"/>
+              <a:alpha val="40000"/>
+            </a:schemeClr>
+          </a:solidFill>
+          <a:ln>
+            <a:noFill/>
+          </a:ln>
+        </p:spPr>
+        <p:style>
+          <a:lnRef idx="2">
+            <a:schemeClr val="accent1">
+              <a:shade val="15000"/>
+            </a:schemeClr>
+          </a:lnRef>
+          <a:fillRef idx="1">
+            <a:schemeClr val="accent1"/>
+          </a:fillRef>
+          <a:effectRef idx="0">
+            <a:schemeClr val="accent1"/>
+          </a:effectRef>
+          <a:fontRef idx="minor">
+            <a:schemeClr val="lt1"/>
+          </a:fontRef>
+        </p:style>
+        <p:txBody>
+          <a:bodyPr rtlCol="0" anchor="ctr"/>
+          <a:lstStyle/>
+          <a:p>
+            <a:pPr algn="ctr"/>
+            <a:endParaRPr lang="en-US"/>
+          </a:p>
+        </p:txBody>
+      </p:sp>
+    </p:spTree>
+    <p:extLst>
+      <p:ext uri="{BB962C8B-B14F-4D97-AF65-F5344CB8AC3E}">
+        <p14:creationId xmlns:p14="http://schemas.microsoft.com/office/powerpoint/2010/main" val="3897272715"/>
+      </p:ext>
+    </p:extLst>
+  </p:cSld>
+  <p:clrMapOvr>
+    <a:masterClrMapping/>
+  </p:clrMapOvr>
+  <p:timing>
+    <p:tnLst>
+      <p:par>
+        <p:cTn id="1" dur="indefinite" restart="never" nodeType="tmRoot">
+          <p:childTnLst>
+            <p:seq concurrent="1" nextAc="seek">
+              <p:cTn id="2" dur="indefinite" nodeType="mainSeq">
+                <p:childTnLst>
+                  <p:par>
+                    <p:cTn id="3" fill="hold">
+                      <p:stCondLst>
+                        <p:cond delay="indefinite"/>
+                      </p:stCondLst>
+                      <p:childTnLst>
+                        <p:par>
+                          <p:cTn id="4" fill="hold">
+                            <p:stCondLst>
+                              <p:cond delay="0"/>
+                            </p:stCondLst>
+                            <p:childTnLst>
+                              <p:par>
+                                <p:cTn id="5" presetID="1" presetClass="entr" presetSubtype="0" fill="hold" grpId="0" nodeType="clickEffect">
+                                  <p:stCondLst>
+                                    <p:cond delay="0"/>
+                                  </p:stCondLst>
+                                  <p:childTnLst>
+                                    <p:set>
+                                      <p:cBhvr>
+                                        <p:cTn id="6" dur="1" fill="hold">
+                                          <p:stCondLst>
+                                            <p:cond delay="0"/>
+                                          </p:stCondLst>
+                                        </p:cTn>
+                                        <p:tgtEl>
+                                          <p:spTgt spid="7"/>
+                                        </p:tgtEl>
+                                        <p:attrNameLst>
+                                          <p:attrName>style.visibility</p:attrName>
+                                        </p:attrNameLst>
+                                      </p:cBhvr>
+                                      <p:to>
+                                        <p:strVal val="visible"/>
+                                      </p:to>
+                                    </p:set>
+                                  </p:childTnLst>
+                                </p:cTn>
+                              </p:par>
+                            </p:childTnLst>
+                          </p:cTn>
+                        </p:par>
+                      </p:childTnLst>
+                    </p:cTn>
+                  </p:par>
+                  <p:par>
+                    <p:cTn id="7" fill="hold">
+                      <p:stCondLst>
+                        <p:cond delay="indefinite"/>
+                      </p:stCondLst>
+                      <p:childTnLst>
+                        <p:par>
+                          <p:cTn id="8" fill="hold">
+                            <p:stCondLst>
+                              <p:cond delay="0"/>
+                            </p:stCondLst>
+                            <p:childTnLst>
+                              <p:par>
+                                <p:cTn id="9" presetID="1" presetClass="entr" presetSubtype="0" fill="hold" nodeType="clickEffect">
+                                  <p:stCondLst>
+                                    <p:cond delay="0"/>
+                                  </p:stCondLst>
+                                  <p:childTnLst>
+                                    <p:set>
+                                      <p:cBhvr>
+                                        <p:cTn id="10" dur="1" fill="hold">
+                                          <p:stCondLst>
+                                            <p:cond delay="0"/>
+                                          </p:stCondLst>
+                                        </p:cTn>
+                                        <p:tgtEl>
+                                          <p:spTgt spid="15"/>
+                                        </p:tgtEl>
+                                        <p:attrNameLst>
+                                          <p:attrName>style.visibility</p:attrName>
+                                        </p:attrNameLst>
+                                      </p:cBhvr>
+                                      <p:to>
+                                        <p:strVal val="visible"/>
+                                      </p:to>
+                                    </p:set>
+                                  </p:childTnLst>
+                                </p:cTn>
+                              </p:par>
+                            </p:childTnLst>
+                          </p:cTn>
+                        </p:par>
+                      </p:childTnLst>
+                    </p:cTn>
+                  </p:par>
+                </p:childTnLst>
+              </p:cTn>
+              <p:prevCondLst>
+                <p:cond evt="onPrev" delay="0">
+                  <p:tgtEl>
+                    <p:sldTgt/>
+                  </p:tgtEl>
+                </p:cond>
+              </p:prevCondLst>
+              <p:nextCondLst>
+                <p:cond evt="onNext" delay="0">
+                  <p:tgtEl>
+                    <p:sldTgt/>
+                  </p:tgtEl>
+                </p:cond>
+              </p:nextCondLst>
+            </p:seq>
+          </p:childTnLst>
+        </p:cTn>
+      </p:par>
+    </p:tnLst>
+    <p:bldLst>
+      <p:bldP spid="7" grpId="0" animBg="1"/>
+    </p:bldLst>
+  </p:timing>
+</p:sld>
+</file>
+
+<file path=ppt/slides/slide52.xml><?xml version="1.0" encoding="utf-8"?>
+<p:sld xmlns:a="http://schemas.openxmlformats.org/drawingml/2006/main" xmlns:r="http://schemas.openxmlformats.org/officeDocument/2006/relationships" xmlns:p="http://schemas.openxmlformats.org/presentationml/2006/main">
+  <p:cSld>
+    <p:spTree>
+      <p:nvGrpSpPr>
+        <p:cNvPr id="1" name=""/>
+        <p:cNvGrpSpPr/>
+        <p:nvPr/>
+      </p:nvGrpSpPr>
+      <p:grpSpPr>
+        <a:xfrm>
+          <a:off x="0" y="0"/>
+          <a:ext cx="0" cy="0"/>
+          <a:chOff x="0" y="0"/>
+          <a:chExt cx="0" cy="0"/>
+        </a:xfrm>
+      </p:grpSpPr>
+      <p:sp>
+        <p:nvSpPr>
+          <p:cNvPr id="2" name="Title 1">
+            <a:extLst>
+              <a:ext uri="{FF2B5EF4-FFF2-40B4-BE49-F238E27FC236}">
                 <a16:creationId xmlns:a16="http://schemas.microsoft.com/office/drawing/2014/main" id="{3CC60B4B-88BC-CFD5-84E5-9BE4E0E29223}"/>
               </a:ext>
             </a:extLst>
@@ -30119,7 +32206,7 @@
           <a:p>
             <a:fld id="{C6EBE6D1-86F0-4C3A-8077-EBA4C5B4BE81}" type="slidenum">
               <a:rPr lang="en-US" smtClean="0"/>
-              <a:t>50</a:t>
+              <a:t>52</a:t>
             </a:fld>
             <a:endParaRPr lang="en-US"/>
           </a:p>
@@ -30168,7 +32255,7 @@
 </p:sld>
 </file>
 
-<file path=ppt/slides/slide51.xml><?xml version="1.0" encoding="utf-8"?>
+<file path=ppt/slides/slide53.xml><?xml version="1.0" encoding="utf-8"?>
 <p:sld xmlns:a="http://schemas.openxmlformats.org/drawingml/2006/main" xmlns:r="http://schemas.openxmlformats.org/officeDocument/2006/relationships" xmlns:p="http://schemas.openxmlformats.org/presentationml/2006/main">
   <p:cSld>
     <p:spTree>
@@ -30339,7 +32426,7 @@
           <a:p>
             <a:fld id="{C6EBE6D1-86F0-4C3A-8077-EBA4C5B4BE81}" type="slidenum">
               <a:rPr lang="en-US" smtClean="0"/>
-              <a:t>51</a:t>
+              <a:t>53</a:t>
             </a:fld>
             <a:endParaRPr lang="en-US"/>
           </a:p>
@@ -30418,7 +32505,7 @@
 </p:sld>
 </file>
 
-<file path=ppt/slides/slide52.xml><?xml version="1.0" encoding="utf-8"?>
+<file path=ppt/slides/slide54.xml><?xml version="1.0" encoding="utf-8"?>
 <p:sld xmlns:a="http://schemas.openxmlformats.org/drawingml/2006/main" xmlns:r="http://schemas.openxmlformats.org/officeDocument/2006/relationships" xmlns:p="http://schemas.openxmlformats.org/presentationml/2006/main">
   <p:cSld>
     <p:spTree>
@@ -30589,7 +32676,7 @@
           <a:p>
             <a:fld id="{C6EBE6D1-86F0-4C3A-8077-EBA4C5B4BE81}" type="slidenum">
               <a:rPr lang="en-US" smtClean="0"/>
-              <a:t>52</a:t>
+              <a:t>54</a:t>
             </a:fld>
             <a:endParaRPr lang="en-US"/>
           </a:p>
@@ -30638,7 +32725,7 @@
 </p:sld>
 </file>
 
-<file path=ppt/slides/slide53.xml><?xml version="1.0" encoding="utf-8"?>
+<file path=ppt/slides/slide55.xml><?xml version="1.0" encoding="utf-8"?>
 <p:sld xmlns:a="http://schemas.openxmlformats.org/drawingml/2006/main" xmlns:r="http://schemas.openxmlformats.org/officeDocument/2006/relationships" xmlns:p="http://schemas.openxmlformats.org/presentationml/2006/main">
   <p:cSld>
     <p:spTree>
@@ -30809,7 +32896,7 @@
           <a:p>
             <a:fld id="{C6EBE6D1-86F0-4C3A-8077-EBA4C5B4BE81}" type="slidenum">
               <a:rPr lang="en-US" smtClean="0"/>
-              <a:t>53</a:t>
+              <a:t>55</a:t>
             </a:fld>
             <a:endParaRPr lang="en-US"/>
           </a:p>
@@ -30888,7 +32975,7 @@
 </p:sld>
 </file>
 
-<file path=ppt/slides/slide54.xml><?xml version="1.0" encoding="utf-8"?>
+<file path=ppt/slides/slide56.xml><?xml version="1.0" encoding="utf-8"?>
 <p:sld xmlns:a="http://schemas.openxmlformats.org/drawingml/2006/main" xmlns:r="http://schemas.openxmlformats.org/officeDocument/2006/relationships" xmlns:p="http://schemas.openxmlformats.org/presentationml/2006/main">
   <p:cSld>
     <p:spTree>
@@ -31059,7 +33146,7 @@
           <a:p>
             <a:fld id="{C6EBE6D1-86F0-4C3A-8077-EBA4C5B4BE81}" type="slidenum">
               <a:rPr lang="en-US" smtClean="0"/>
-              <a:t>54</a:t>
+              <a:t>56</a:t>
             </a:fld>
             <a:endParaRPr lang="en-US"/>
           </a:p>
@@ -31138,7 +33225,7 @@
 </p:sld>
 </file>
 
-<file path=ppt/slides/slide55.xml><?xml version="1.0" encoding="utf-8"?>
+<file path=ppt/slides/slide57.xml><?xml version="1.0" encoding="utf-8"?>
 <p:sld xmlns:a="http://schemas.openxmlformats.org/drawingml/2006/main" xmlns:r="http://schemas.openxmlformats.org/officeDocument/2006/relationships" xmlns:p="http://schemas.openxmlformats.org/presentationml/2006/main">
   <p:cSld>
     <p:spTree>
@@ -31300,7 +33387,7 @@
           <a:p>
             <a:fld id="{C6EBE6D1-86F0-4C3A-8077-EBA4C5B4BE81}" type="slidenum">
               <a:rPr lang="en-US" smtClean="0"/>
-              <a:t>55</a:t>
+              <a:t>57</a:t>
             </a:fld>
             <a:endParaRPr lang="en-US"/>
           </a:p>
@@ -31483,7 +33570,7 @@
 </p:sld>
 </file>
 
-<file path=ppt/slides/slide56.xml><?xml version="1.0" encoding="utf-8"?>
+<file path=ppt/slides/slide58.xml><?xml version="1.0" encoding="utf-8"?>
 <p:sld xmlns:a="http://schemas.openxmlformats.org/drawingml/2006/main" xmlns:r="http://schemas.openxmlformats.org/officeDocument/2006/relationships" xmlns:p="http://schemas.openxmlformats.org/presentationml/2006/main">
   <p:cSld>
     <p:spTree>
@@ -31632,7 +33719,7 @@
           <a:p>
             <a:fld id="{C6EBE6D1-86F0-4C3A-8077-EBA4C5B4BE81}" type="slidenum">
               <a:rPr lang="en-US" smtClean="0"/>
-              <a:t>56</a:t>
+              <a:t>58</a:t>
             </a:fld>
             <a:endParaRPr lang="en-US"/>
           </a:p>
@@ -31651,7 +33738,7 @@
 </p:sld>
 </file>
 
-<file path=ppt/slides/slide57.xml><?xml version="1.0" encoding="utf-8"?>
+<file path=ppt/slides/slide59.xml><?xml version="1.0" encoding="utf-8"?>
 <p:sld xmlns:a="http://schemas.openxmlformats.org/drawingml/2006/main" xmlns:r="http://schemas.openxmlformats.org/officeDocument/2006/relationships" xmlns:p="http://schemas.openxmlformats.org/presentationml/2006/main">
   <p:cSld>
     <p:spTree>
@@ -31775,7 +33862,7 @@
           <a:p>
             <a:fld id="{C6EBE6D1-86F0-4C3A-8077-EBA4C5B4BE81}" type="slidenum">
               <a:rPr lang="en-US" smtClean="0"/>
-              <a:t>57</a:t>
+              <a:t>59</a:t>
             </a:fld>
             <a:endParaRPr lang="en-US"/>
           </a:p>
@@ -32487,7 +34574,7 @@
 </p:sld>
 </file>
 
-<file path=ppt/slides/slide58.xml><?xml version="1.0" encoding="utf-8"?>
+<file path=ppt/slides/slide6.xml><?xml version="1.0" encoding="utf-8"?>
 <p:sld xmlns:a="http://schemas.openxmlformats.org/drawingml/2006/main" xmlns:r="http://schemas.openxmlformats.org/officeDocument/2006/relationships" xmlns:p="http://schemas.openxmlformats.org/presentationml/2006/main">
   <p:cSld>
     <p:spTree>
@@ -32506,6 +34593,177 @@
       </p:grpSpPr>
       <p:sp>
         <p:nvSpPr>
+          <p:cNvPr id="4" name="Title 3">
+            <a:extLst>
+              <a:ext uri="{FF2B5EF4-FFF2-40B4-BE49-F238E27FC236}">
+                <a16:creationId xmlns:a16="http://schemas.microsoft.com/office/drawing/2014/main" id="{3FB8724D-4A2D-EF8F-72D8-A63F6DDDA9C4}"/>
+              </a:ext>
+            </a:extLst>
+          </p:cNvPr>
+          <p:cNvSpPr>
+            <a:spLocks noGrp="1"/>
+          </p:cNvSpPr>
+          <p:nvPr>
+            <p:ph type="title"/>
+          </p:nvPr>
+        </p:nvSpPr>
+        <p:spPr/>
+        <p:txBody>
+          <a:bodyPr/>
+          <a:lstStyle/>
+          <a:p>
+            <a:r>
+              <a:rPr lang="en-US" dirty="0"/>
+              <a:t>Statistical Causal Inference</a:t>
+            </a:r>
+          </a:p>
+        </p:txBody>
+      </p:sp>
+      <p:sp>
+        <p:nvSpPr>
+          <p:cNvPr id="5" name="Text Placeholder 4">
+            <a:extLst>
+              <a:ext uri="{FF2B5EF4-FFF2-40B4-BE49-F238E27FC236}">
+                <a16:creationId xmlns:a16="http://schemas.microsoft.com/office/drawing/2014/main" id="{E407892A-18FC-6BF0-5A4A-A73AFF72D71E}"/>
+              </a:ext>
+            </a:extLst>
+          </p:cNvPr>
+          <p:cNvSpPr>
+            <a:spLocks noGrp="1"/>
+          </p:cNvSpPr>
+          <p:nvPr>
+            <p:ph type="body" idx="1"/>
+          </p:nvPr>
+        </p:nvSpPr>
+        <p:spPr/>
+        <p:txBody>
+          <a:bodyPr/>
+          <a:lstStyle/>
+          <a:p>
+            <a:r>
+              <a:rPr lang="en-US" dirty="0"/>
+              <a:t>A rigorous approach to obtaining valid conclusions from data</a:t>
+            </a:r>
+          </a:p>
+        </p:txBody>
+      </p:sp>
+      <p:sp>
+        <p:nvSpPr>
+          <p:cNvPr id="2" name="Date Placeholder 1">
+            <a:extLst>
+              <a:ext uri="{FF2B5EF4-FFF2-40B4-BE49-F238E27FC236}">
+                <a16:creationId xmlns:a16="http://schemas.microsoft.com/office/drawing/2014/main" id="{48D72B3E-E6C9-8CAA-9D68-2B5DA476EDE9}"/>
+              </a:ext>
+            </a:extLst>
+          </p:cNvPr>
+          <p:cNvSpPr>
+            <a:spLocks noGrp="1"/>
+          </p:cNvSpPr>
+          <p:nvPr>
+            <p:ph type="dt" sz="half" idx="10"/>
+          </p:nvPr>
+        </p:nvSpPr>
+        <p:spPr/>
+        <p:txBody>
+          <a:bodyPr/>
+          <a:lstStyle/>
+          <a:p>
+            <a:r>
+              <a:rPr lang="en-US"/>
+              <a:t>2024-10-17</a:t>
+            </a:r>
+          </a:p>
+        </p:txBody>
+      </p:sp>
+      <p:sp>
+        <p:nvSpPr>
+          <p:cNvPr id="3" name="Footer Placeholder 2">
+            <a:extLst>
+              <a:ext uri="{FF2B5EF4-FFF2-40B4-BE49-F238E27FC236}">
+                <a16:creationId xmlns:a16="http://schemas.microsoft.com/office/drawing/2014/main" id="{841E30C1-85A3-70CF-6D98-0B52E676F5D2}"/>
+              </a:ext>
+            </a:extLst>
+          </p:cNvPr>
+          <p:cNvSpPr>
+            <a:spLocks noGrp="1"/>
+          </p:cNvSpPr>
+          <p:nvPr>
+            <p:ph type="ftr" sz="quarter" idx="11"/>
+          </p:nvPr>
+        </p:nvSpPr>
+        <p:spPr/>
+        <p:txBody>
+          <a:bodyPr/>
+          <a:lstStyle/>
+          <a:p>
+            <a:r>
+              <a:rPr lang="en-US"/>
+              <a:t>Bayesian Data Analysis for Statistical Causal Inference</a:t>
+            </a:r>
+          </a:p>
+        </p:txBody>
+      </p:sp>
+      <p:sp>
+        <p:nvSpPr>
+          <p:cNvPr id="6" name="Slide Number Placeholder 5">
+            <a:extLst>
+              <a:ext uri="{FF2B5EF4-FFF2-40B4-BE49-F238E27FC236}">
+                <a16:creationId xmlns:a16="http://schemas.microsoft.com/office/drawing/2014/main" id="{DCB47D23-5EEA-5E33-E367-E79E82B33727}"/>
+              </a:ext>
+            </a:extLst>
+          </p:cNvPr>
+          <p:cNvSpPr>
+            <a:spLocks noGrp="1"/>
+          </p:cNvSpPr>
+          <p:nvPr>
+            <p:ph type="sldNum" sz="quarter" idx="12"/>
+          </p:nvPr>
+        </p:nvSpPr>
+        <p:spPr/>
+        <p:txBody>
+          <a:bodyPr/>
+          <a:lstStyle/>
+          <a:p>
+            <a:fld id="{C6EBE6D1-86F0-4C3A-8077-EBA4C5B4BE81}" type="slidenum">
+              <a:rPr lang="en-US" smtClean="0"/>
+              <a:t>6</a:t>
+            </a:fld>
+            <a:endParaRPr lang="en-US"/>
+          </a:p>
+        </p:txBody>
+      </p:sp>
+    </p:spTree>
+    <p:extLst>
+      <p:ext uri="{BB962C8B-B14F-4D97-AF65-F5344CB8AC3E}">
+        <p14:creationId xmlns:p14="http://schemas.microsoft.com/office/powerpoint/2010/main" val="3766653951"/>
+      </p:ext>
+    </p:extLst>
+  </p:cSld>
+  <p:clrMapOvr>
+    <a:masterClrMapping/>
+  </p:clrMapOvr>
+</p:sld>
+</file>
+
+<file path=ppt/slides/slide60.xml><?xml version="1.0" encoding="utf-8"?>
+<p:sld xmlns:a="http://schemas.openxmlformats.org/drawingml/2006/main" xmlns:r="http://schemas.openxmlformats.org/officeDocument/2006/relationships" xmlns:p="http://schemas.openxmlformats.org/presentationml/2006/main">
+  <p:cSld>
+    <p:spTree>
+      <p:nvGrpSpPr>
+        <p:cNvPr id="1" name=""/>
+        <p:cNvGrpSpPr/>
+        <p:nvPr/>
+      </p:nvGrpSpPr>
+      <p:grpSpPr>
+        <a:xfrm>
+          <a:off x="0" y="0"/>
+          <a:ext cx="0" cy="0"/>
+          <a:chOff x="0" y="0"/>
+          <a:chExt cx="0" cy="0"/>
+        </a:xfrm>
+      </p:grpSpPr>
+      <p:sp>
+        <p:nvSpPr>
           <p:cNvPr id="2" name="Title 1">
             <a:extLst>
               <a:ext uri="{FF2B5EF4-FFF2-40B4-BE49-F238E27FC236}">
@@ -32611,7 +34869,7 @@
           <a:p>
             <a:fld id="{C6EBE6D1-86F0-4C3A-8077-EBA4C5B4BE81}" type="slidenum">
               <a:rPr lang="en-US" smtClean="0"/>
-              <a:t>58</a:t>
+              <a:t>60</a:t>
             </a:fld>
             <a:endParaRPr lang="en-US"/>
           </a:p>
@@ -33458,177 +35716,6 @@
       </p:par>
     </p:tnLst>
   </p:timing>
-</p:sld>
-</file>
-
-<file path=ppt/slides/slide6.xml><?xml version="1.0" encoding="utf-8"?>
-<p:sld xmlns:a="http://schemas.openxmlformats.org/drawingml/2006/main" xmlns:r="http://schemas.openxmlformats.org/officeDocument/2006/relationships" xmlns:p="http://schemas.openxmlformats.org/presentationml/2006/main">
-  <p:cSld>
-    <p:spTree>
-      <p:nvGrpSpPr>
-        <p:cNvPr id="1" name=""/>
-        <p:cNvGrpSpPr/>
-        <p:nvPr/>
-      </p:nvGrpSpPr>
-      <p:grpSpPr>
-        <a:xfrm>
-          <a:off x="0" y="0"/>
-          <a:ext cx="0" cy="0"/>
-          <a:chOff x="0" y="0"/>
-          <a:chExt cx="0" cy="0"/>
-        </a:xfrm>
-      </p:grpSpPr>
-      <p:sp>
-        <p:nvSpPr>
-          <p:cNvPr id="4" name="Title 3">
-            <a:extLst>
-              <a:ext uri="{FF2B5EF4-FFF2-40B4-BE49-F238E27FC236}">
-                <a16:creationId xmlns:a16="http://schemas.microsoft.com/office/drawing/2014/main" id="{3FB8724D-4A2D-EF8F-72D8-A63F6DDDA9C4}"/>
-              </a:ext>
-            </a:extLst>
-          </p:cNvPr>
-          <p:cNvSpPr>
-            <a:spLocks noGrp="1"/>
-          </p:cNvSpPr>
-          <p:nvPr>
-            <p:ph type="title"/>
-          </p:nvPr>
-        </p:nvSpPr>
-        <p:spPr/>
-        <p:txBody>
-          <a:bodyPr/>
-          <a:lstStyle/>
-          <a:p>
-            <a:r>
-              <a:rPr lang="en-US" dirty="0"/>
-              <a:t>Statistical Causal Inference</a:t>
-            </a:r>
-          </a:p>
-        </p:txBody>
-      </p:sp>
-      <p:sp>
-        <p:nvSpPr>
-          <p:cNvPr id="5" name="Text Placeholder 4">
-            <a:extLst>
-              <a:ext uri="{FF2B5EF4-FFF2-40B4-BE49-F238E27FC236}">
-                <a16:creationId xmlns:a16="http://schemas.microsoft.com/office/drawing/2014/main" id="{E407892A-18FC-6BF0-5A4A-A73AFF72D71E}"/>
-              </a:ext>
-            </a:extLst>
-          </p:cNvPr>
-          <p:cNvSpPr>
-            <a:spLocks noGrp="1"/>
-          </p:cNvSpPr>
-          <p:nvPr>
-            <p:ph type="body" idx="1"/>
-          </p:nvPr>
-        </p:nvSpPr>
-        <p:spPr/>
-        <p:txBody>
-          <a:bodyPr/>
-          <a:lstStyle/>
-          <a:p>
-            <a:r>
-              <a:rPr lang="en-US" dirty="0"/>
-              <a:t>A rigorous approach to obtaining valid conclusions from data</a:t>
-            </a:r>
-          </a:p>
-        </p:txBody>
-      </p:sp>
-      <p:sp>
-        <p:nvSpPr>
-          <p:cNvPr id="2" name="Date Placeholder 1">
-            <a:extLst>
-              <a:ext uri="{FF2B5EF4-FFF2-40B4-BE49-F238E27FC236}">
-                <a16:creationId xmlns:a16="http://schemas.microsoft.com/office/drawing/2014/main" id="{48D72B3E-E6C9-8CAA-9D68-2B5DA476EDE9}"/>
-              </a:ext>
-            </a:extLst>
-          </p:cNvPr>
-          <p:cNvSpPr>
-            <a:spLocks noGrp="1"/>
-          </p:cNvSpPr>
-          <p:nvPr>
-            <p:ph type="dt" sz="half" idx="10"/>
-          </p:nvPr>
-        </p:nvSpPr>
-        <p:spPr/>
-        <p:txBody>
-          <a:bodyPr/>
-          <a:lstStyle/>
-          <a:p>
-            <a:r>
-              <a:rPr lang="en-US"/>
-              <a:t>2024-10-17</a:t>
-            </a:r>
-          </a:p>
-        </p:txBody>
-      </p:sp>
-      <p:sp>
-        <p:nvSpPr>
-          <p:cNvPr id="3" name="Footer Placeholder 2">
-            <a:extLst>
-              <a:ext uri="{FF2B5EF4-FFF2-40B4-BE49-F238E27FC236}">
-                <a16:creationId xmlns:a16="http://schemas.microsoft.com/office/drawing/2014/main" id="{841E30C1-85A3-70CF-6D98-0B52E676F5D2}"/>
-              </a:ext>
-            </a:extLst>
-          </p:cNvPr>
-          <p:cNvSpPr>
-            <a:spLocks noGrp="1"/>
-          </p:cNvSpPr>
-          <p:nvPr>
-            <p:ph type="ftr" sz="quarter" idx="11"/>
-          </p:nvPr>
-        </p:nvSpPr>
-        <p:spPr/>
-        <p:txBody>
-          <a:bodyPr/>
-          <a:lstStyle/>
-          <a:p>
-            <a:r>
-              <a:rPr lang="en-US"/>
-              <a:t>Bayesian Data Analysis for Statistical Causal Inference</a:t>
-            </a:r>
-          </a:p>
-        </p:txBody>
-      </p:sp>
-      <p:sp>
-        <p:nvSpPr>
-          <p:cNvPr id="6" name="Slide Number Placeholder 5">
-            <a:extLst>
-              <a:ext uri="{FF2B5EF4-FFF2-40B4-BE49-F238E27FC236}">
-                <a16:creationId xmlns:a16="http://schemas.microsoft.com/office/drawing/2014/main" id="{DCB47D23-5EEA-5E33-E367-E79E82B33727}"/>
-              </a:ext>
-            </a:extLst>
-          </p:cNvPr>
-          <p:cNvSpPr>
-            <a:spLocks noGrp="1"/>
-          </p:cNvSpPr>
-          <p:nvPr>
-            <p:ph type="sldNum" sz="quarter" idx="12"/>
-          </p:nvPr>
-        </p:nvSpPr>
-        <p:spPr/>
-        <p:txBody>
-          <a:bodyPr/>
-          <a:lstStyle/>
-          <a:p>
-            <a:fld id="{C6EBE6D1-86F0-4C3A-8077-EBA4C5B4BE81}" type="slidenum">
-              <a:rPr lang="en-US" smtClean="0"/>
-              <a:t>6</a:t>
-            </a:fld>
-            <a:endParaRPr lang="en-US"/>
-          </a:p>
-        </p:txBody>
-      </p:sp>
-    </p:spTree>
-    <p:extLst>
-      <p:ext uri="{BB962C8B-B14F-4D97-AF65-F5344CB8AC3E}">
-        <p14:creationId xmlns:p14="http://schemas.microsoft.com/office/powerpoint/2010/main" val="3766653951"/>
-      </p:ext>
-    </p:extLst>
-  </p:cSld>
-  <p:clrMapOvr>
-    <a:masterClrMapping/>
-  </p:clrMapOvr>
 </p:sld>
 </file>
 

</xml_diff>